<commit_message>
What We Do deck — 15-minute version, one $399 package
</commit_message>
<xml_diff>
--- a/assets/Southern-Oak-What-We-Do.pptx
+++ b/assets/Southern-Oak-What-We-Do.pptx
@@ -6,17 +6,21 @@
   </p:sldMasterIdLst>
   <p:sldIdLst>
     <p:sldId id="256" r:id="rId7"/>
-    <p:sldId id="257" r:id="rId8"/>
-    <p:sldId id="258" r:id="rId9"/>
-    <p:sldId id="259" r:id="rId10"/>
-    <p:sldId id="260" r:id="rId11"/>
-    <p:sldId id="261" r:id="rId12"/>
-    <p:sldId id="262" r:id="rId13"/>
-    <p:sldId id="263" r:id="rId14"/>
-    <p:sldId id="264" r:id="rId15"/>
-    <p:sldId id="265" r:id="rId16"/>
-    <p:sldId id="266" r:id="rId17"/>
-    <p:sldId id="267" r:id="rId18"/>
+    <p:sldId id="257" r:id="rId9"/>
+    <p:sldId id="258" r:id="rId10"/>
+    <p:sldId id="259" r:id="rId11"/>
+    <p:sldId id="260" r:id="rId12"/>
+    <p:sldId id="261" r:id="rId13"/>
+    <p:sldId id="262" r:id="rId14"/>
+    <p:sldId id="263" r:id="rId15"/>
+    <p:sldId id="264" r:id="rId16"/>
+    <p:sldId id="265" r:id="rId17"/>
+    <p:sldId id="266" r:id="rId18"/>
+    <p:sldId id="267" r:id="rId19"/>
+    <p:sldId id="268" r:id="rId20"/>
+    <p:sldId id="269" r:id="rId21"/>
+    <p:sldId id="270" r:id="rId22"/>
+    <p:sldId id="271" r:id="rId23"/>
   </p:sldIdLst>
   <p:sldSz cx="12191695" cy="6858000" type="screen4x3"/>
   <p:notesSz cx="6858000" cy="9144000"/>
@@ -116,6 +120,1476 @@
     </a:lvl9pPr>
   </p:defaultTextStyle>
 </p:presentation>
+</file>
+
+<file path=ppt/notesMasters/notesMaster1.xml><?xml version="1.0" encoding="utf-8"?>
+<p:notesMaster xmlns:a="http://schemas.openxmlformats.org/drawingml/2006/main" xmlns:p="http://schemas.openxmlformats.org/presentationml/2006/main" xmlns:r="http://schemas.openxmlformats.org/officeDocument/2006/relationships">
+  <p:cSld>
+    <p:bg>
+      <p:bgRef idx="1001">
+        <a:schemeClr val="bg1"/>
+      </p:bgRef>
+    </p:bg>
+    <p:spTree>
+      <p:nvGrpSpPr>
+        <p:cNvPr id="1" name=""/>
+        <p:cNvGrpSpPr/>
+        <p:nvPr/>
+      </p:nvGrpSpPr>
+      <p:grpSpPr>
+        <a:xfrm>
+          <a:off x="0" y="0"/>
+          <a:ext cx="0" cy="0"/>
+          <a:chOff x="0" y="0"/>
+          <a:chExt cx="0" cy="0"/>
+        </a:xfrm>
+      </p:grpSpPr>
+      <p:sp>
+        <p:nvSpPr>
+          <p:cNvPr id="2" name="Header Placeholder 1"/>
+          <p:cNvSpPr>
+            <a:spLocks noGrp="1"/>
+          </p:cNvSpPr>
+          <p:nvPr>
+            <p:ph type="hdr" sz="quarter"/>
+          </p:nvPr>
+        </p:nvSpPr>
+        <p:spPr>
+          <a:xfrm>
+            <a:off x="0" y="0"/>
+            <a:ext cx="2971800" cy="457200"/>
+          </a:xfrm>
+          <a:prstGeom prst="rect">
+            <a:avLst/>
+          </a:prstGeom>
+        </p:spPr>
+        <p:txBody>
+          <a:bodyPr vert="horz" lIns="91440" tIns="45720" rIns="91440" bIns="45720" rtlCol="0"/>
+          <a:lstStyle>
+            <a:lvl1pPr algn="l">
+              <a:defRPr sz="1200"/>
+            </a:lvl1pPr>
+          </a:lstStyle>
+          <a:p>
+            <a:endParaRPr lang="en-US"/>
+          </a:p>
+        </p:txBody>
+      </p:sp>
+      <p:sp>
+        <p:nvSpPr>
+          <p:cNvPr id="3" name="Date Placeholder 2"/>
+          <p:cNvSpPr>
+            <a:spLocks noGrp="1"/>
+          </p:cNvSpPr>
+          <p:nvPr>
+            <p:ph type="dt" idx="1"/>
+          </p:nvPr>
+        </p:nvSpPr>
+        <p:spPr>
+          <a:xfrm>
+            <a:off x="3884613" y="0"/>
+            <a:ext cx="2971800" cy="457200"/>
+          </a:xfrm>
+          <a:prstGeom prst="rect">
+            <a:avLst/>
+          </a:prstGeom>
+        </p:spPr>
+        <p:txBody>
+          <a:bodyPr vert="horz" lIns="91440" tIns="45720" rIns="91440" bIns="45720" rtlCol="0"/>
+          <a:lstStyle>
+            <a:lvl1pPr algn="r">
+              <a:defRPr sz="1200"/>
+            </a:lvl1pPr>
+          </a:lstStyle>
+          <a:p>
+            <a:fld id="{0F89C1C7-3DCD-1040-A9CF-14679D8B5DDD}" type="datetimeFigureOut">
+              <a:rPr lang="en-US" smtClean="0"/>
+              <a:t>10/17/16</a:t>
+            </a:fld>
+            <a:endParaRPr lang="en-US"/>
+          </a:p>
+        </p:txBody>
+      </p:sp>
+      <p:sp>
+        <p:nvSpPr>
+          <p:cNvPr id="4" name="Slide Image Placeholder 3"/>
+          <p:cNvSpPr>
+            <a:spLocks noGrp="1" noRot="1" noChangeAspect="1"/>
+          </p:cNvSpPr>
+          <p:nvPr>
+            <p:ph type="sldImg" idx="2"/>
+          </p:nvPr>
+        </p:nvSpPr>
+        <p:spPr>
+          <a:xfrm>
+            <a:off x="1143000" y="685800"/>
+            <a:ext cx="4572000" cy="3429000"/>
+          </a:xfrm>
+          <a:prstGeom prst="rect">
+            <a:avLst/>
+          </a:prstGeom>
+          <a:noFill/>
+          <a:ln w="12700">
+            <a:solidFill>
+              <a:prstClr val="black"/>
+            </a:solidFill>
+          </a:ln>
+        </p:spPr>
+        <p:txBody>
+          <a:bodyPr vert="horz" lIns="91440" tIns="45720" rIns="91440" bIns="45720" rtlCol="0" anchor="ctr"/>
+          <a:lstStyle/>
+          <a:p>
+            <a:endParaRPr lang="en-US"/>
+          </a:p>
+        </p:txBody>
+      </p:sp>
+      <p:sp>
+        <p:nvSpPr>
+          <p:cNvPr id="5" name="Notes Placeholder 4"/>
+          <p:cNvSpPr>
+            <a:spLocks noGrp="1"/>
+          </p:cNvSpPr>
+          <p:nvPr>
+            <p:ph type="body" sz="quarter" idx="3"/>
+          </p:nvPr>
+        </p:nvSpPr>
+        <p:spPr>
+          <a:xfrm>
+            <a:off x="685800" y="4343400"/>
+            <a:ext cx="5486400" cy="4114800"/>
+          </a:xfrm>
+          <a:prstGeom prst="rect">
+            <a:avLst/>
+          </a:prstGeom>
+        </p:spPr>
+        <p:txBody>
+          <a:bodyPr vert="horz" lIns="91440" tIns="45720" rIns="91440" bIns="45720" rtlCol="0"/>
+          <a:lstStyle/>
+          <a:p>
+            <a:pPr lvl="0"/>
+            <a:r>
+              <a:rPr lang="en-US" smtClean="0"/>
+              <a:t>Click to edit Master text styles</a:t>
+            </a:r>
+          </a:p>
+          <a:p>
+            <a:pPr lvl="1"/>
+            <a:r>
+              <a:rPr lang="en-US" smtClean="0"/>
+              <a:t>Second level</a:t>
+            </a:r>
+          </a:p>
+          <a:p>
+            <a:pPr lvl="2"/>
+            <a:r>
+              <a:rPr lang="en-US" smtClean="0"/>
+              <a:t>Third level</a:t>
+            </a:r>
+          </a:p>
+          <a:p>
+            <a:pPr lvl="3"/>
+            <a:r>
+              <a:rPr lang="en-US" smtClean="0"/>
+              <a:t>Fourth level</a:t>
+            </a:r>
+          </a:p>
+          <a:p>
+            <a:pPr lvl="4"/>
+            <a:r>
+              <a:rPr lang="en-US" smtClean="0"/>
+              <a:t>Fifth level</a:t>
+            </a:r>
+            <a:endParaRPr lang="en-US"/>
+          </a:p>
+        </p:txBody>
+      </p:sp>
+      <p:sp>
+        <p:nvSpPr>
+          <p:cNvPr id="6" name="Footer Placeholder 5"/>
+          <p:cNvSpPr>
+            <a:spLocks noGrp="1"/>
+          </p:cNvSpPr>
+          <p:nvPr>
+            <p:ph type="ftr" sz="quarter" idx="4"/>
+          </p:nvPr>
+        </p:nvSpPr>
+        <p:spPr>
+          <a:xfrm>
+            <a:off x="0" y="8685213"/>
+            <a:ext cx="2971800" cy="457200"/>
+          </a:xfrm>
+          <a:prstGeom prst="rect">
+            <a:avLst/>
+          </a:prstGeom>
+        </p:spPr>
+        <p:txBody>
+          <a:bodyPr vert="horz" lIns="91440" tIns="45720" rIns="91440" bIns="45720" rtlCol="0" anchor="b"/>
+          <a:lstStyle>
+            <a:lvl1pPr algn="l">
+              <a:defRPr sz="1200"/>
+            </a:lvl1pPr>
+          </a:lstStyle>
+          <a:p>
+            <a:endParaRPr lang="en-US"/>
+          </a:p>
+        </p:txBody>
+      </p:sp>
+      <p:sp>
+        <p:nvSpPr>
+          <p:cNvPr id="7" name="Slide Number Placeholder 6"/>
+          <p:cNvSpPr>
+            <a:spLocks noGrp="1"/>
+          </p:cNvSpPr>
+          <p:nvPr>
+            <p:ph type="sldNum" sz="quarter" idx="5"/>
+          </p:nvPr>
+        </p:nvSpPr>
+        <p:spPr>
+          <a:xfrm>
+            <a:off x="3884613" y="8685213"/>
+            <a:ext cx="2971800" cy="457200"/>
+          </a:xfrm>
+          <a:prstGeom prst="rect">
+            <a:avLst/>
+          </a:prstGeom>
+        </p:spPr>
+        <p:txBody>
+          <a:bodyPr vert="horz" lIns="91440" tIns="45720" rIns="91440" bIns="45720" rtlCol="0" anchor="b"/>
+          <a:lstStyle>
+            <a:lvl1pPr algn="r">
+              <a:defRPr sz="1200"/>
+            </a:lvl1pPr>
+          </a:lstStyle>
+          <a:p>
+            <a:fld id="{BB5E49A5-4136-284D-997B-48E1D791AD67}" type="slidenum">
+              <a:rPr lang="en-US" smtClean="0"/>
+              <a:t>‹#›</a:t>
+            </a:fld>
+            <a:endParaRPr lang="en-US"/>
+          </a:p>
+        </p:txBody>
+      </p:sp>
+    </p:spTree>
+    <p:extLst>
+      <p:ext uri="{BB962C8B-B14F-4D97-AF65-F5344CB8AC3E}">
+        <p14:creationId xmlns:p14="http://schemas.microsoft.com/office/powerpoint/2010/main" val="2623252185"/>
+      </p:ext>
+    </p:extLst>
+  </p:cSld>
+  <p:clrMap bg1="lt1" tx1="dk1" bg2="lt2" tx2="dk2" accent1="accent1" accent2="accent2" accent3="accent3" accent4="accent4" accent5="accent5" accent6="accent6" hlink="hlink" folHlink="folHlink"/>
+  <p:notesStyle>
+    <a:lvl1pPr marL="0" algn="l" defTabSz="457200" rtl="0" eaLnBrk="1" latinLnBrk="0" hangingPunct="1">
+      <a:defRPr sz="1200" kern="1200">
+        <a:solidFill>
+          <a:schemeClr val="tx1"/>
+        </a:solidFill>
+        <a:latin typeface="+mn-lt"/>
+        <a:ea typeface="+mn-ea"/>
+        <a:cs typeface="+mn-cs"/>
+      </a:defRPr>
+    </a:lvl1pPr>
+    <a:lvl2pPr marL="457200" algn="l" defTabSz="457200" rtl="0" eaLnBrk="1" latinLnBrk="0" hangingPunct="1">
+      <a:defRPr sz="1200" kern="1200">
+        <a:solidFill>
+          <a:schemeClr val="tx1"/>
+        </a:solidFill>
+        <a:latin typeface="+mn-lt"/>
+        <a:ea typeface="+mn-ea"/>
+        <a:cs typeface="+mn-cs"/>
+      </a:defRPr>
+    </a:lvl2pPr>
+    <a:lvl3pPr marL="914400" algn="l" defTabSz="457200" rtl="0" eaLnBrk="1" latinLnBrk="0" hangingPunct="1">
+      <a:defRPr sz="1200" kern="1200">
+        <a:solidFill>
+          <a:schemeClr val="tx1"/>
+        </a:solidFill>
+        <a:latin typeface="+mn-lt"/>
+        <a:ea typeface="+mn-ea"/>
+        <a:cs typeface="+mn-cs"/>
+      </a:defRPr>
+    </a:lvl3pPr>
+    <a:lvl4pPr marL="1371600" algn="l" defTabSz="457200" rtl="0" eaLnBrk="1" latinLnBrk="0" hangingPunct="1">
+      <a:defRPr sz="1200" kern="1200">
+        <a:solidFill>
+          <a:schemeClr val="tx1"/>
+        </a:solidFill>
+        <a:latin typeface="+mn-lt"/>
+        <a:ea typeface="+mn-ea"/>
+        <a:cs typeface="+mn-cs"/>
+      </a:defRPr>
+    </a:lvl4pPr>
+    <a:lvl5pPr marL="1828800" algn="l" defTabSz="457200" rtl="0" eaLnBrk="1" latinLnBrk="0" hangingPunct="1">
+      <a:defRPr sz="1200" kern="1200">
+        <a:solidFill>
+          <a:schemeClr val="tx1"/>
+        </a:solidFill>
+        <a:latin typeface="+mn-lt"/>
+        <a:ea typeface="+mn-ea"/>
+        <a:cs typeface="+mn-cs"/>
+      </a:defRPr>
+    </a:lvl5pPr>
+    <a:lvl6pPr marL="2286000" algn="l" defTabSz="457200" rtl="0" eaLnBrk="1" latinLnBrk="0" hangingPunct="1">
+      <a:defRPr sz="1200" kern="1200">
+        <a:solidFill>
+          <a:schemeClr val="tx1"/>
+        </a:solidFill>
+        <a:latin typeface="+mn-lt"/>
+        <a:ea typeface="+mn-ea"/>
+        <a:cs typeface="+mn-cs"/>
+      </a:defRPr>
+    </a:lvl6pPr>
+    <a:lvl7pPr marL="2743200" algn="l" defTabSz="457200" rtl="0" eaLnBrk="1" latinLnBrk="0" hangingPunct="1">
+      <a:defRPr sz="1200" kern="1200">
+        <a:solidFill>
+          <a:schemeClr val="tx1"/>
+        </a:solidFill>
+        <a:latin typeface="+mn-lt"/>
+        <a:ea typeface="+mn-ea"/>
+        <a:cs typeface="+mn-cs"/>
+      </a:defRPr>
+    </a:lvl7pPr>
+    <a:lvl8pPr marL="3200400" algn="l" defTabSz="457200" rtl="0" eaLnBrk="1" latinLnBrk="0" hangingPunct="1">
+      <a:defRPr sz="1200" kern="1200">
+        <a:solidFill>
+          <a:schemeClr val="tx1"/>
+        </a:solidFill>
+        <a:latin typeface="+mn-lt"/>
+        <a:ea typeface="+mn-ea"/>
+        <a:cs typeface="+mn-cs"/>
+      </a:defRPr>
+    </a:lvl8pPr>
+    <a:lvl9pPr marL="3657600" algn="l" defTabSz="457200" rtl="0" eaLnBrk="1" latinLnBrk="0" hangingPunct="1">
+      <a:defRPr sz="1200" kern="1200">
+        <a:solidFill>
+          <a:schemeClr val="tx1"/>
+        </a:solidFill>
+        <a:latin typeface="+mn-lt"/>
+        <a:ea typeface="+mn-ea"/>
+        <a:cs typeface="+mn-cs"/>
+      </a:defRPr>
+    </a:lvl9pPr>
+  </p:notesStyle>
+</p:notesMaster>
+</file>
+
+<file path=ppt/notesSlides/notesSlide1.xml><?xml version="1.0" encoding="utf-8"?>
+<p:notes xmlns:a="http://schemas.openxmlformats.org/drawingml/2006/main" xmlns:p="http://schemas.openxmlformats.org/presentationml/2006/main" xmlns:r="http://schemas.openxmlformats.org/officeDocument/2006/relationships">
+  <p:cSld>
+    <p:spTree>
+      <p:nvGrpSpPr>
+        <p:cNvPr id="1" name=""/>
+        <p:cNvGrpSpPr/>
+        <p:nvPr/>
+      </p:nvGrpSpPr>
+      <p:grpSpPr>
+        <a:xfrm>
+          <a:off x="0" y="0"/>
+          <a:ext cx="0" cy="0"/>
+          <a:chOff x="0" y="0"/>
+          <a:chExt cx="0" cy="0"/>
+        </a:xfrm>
+      </p:grpSpPr>
+      <p:sp>
+        <p:nvSpPr>
+          <p:cNvPr id="2" name="Slide Image Placeholder 1"/>
+          <p:cNvSpPr>
+            <a:spLocks noGrp="1"/>
+          </p:cNvSpPr>
+          <p:nvPr>
+            <p:ph type="sldImg" idx="2"/>
+          </p:nvPr>
+        </p:nvSpPr>
+        <p:spPr/>
+      </p:sp>
+      <p:sp>
+        <p:nvSpPr>
+          <p:cNvPr id="3" name="Notes Placeholder 2"/>
+          <p:cNvSpPr>
+            <a:spLocks noGrp="1"/>
+          </p:cNvSpPr>
+          <p:nvPr>
+            <p:ph type="body" idx="3" sz="quarter"/>
+          </p:nvPr>
+        </p:nvSpPr>
+        <p:spPr/>
+        <p:txBody>
+          <a:bodyPr/>
+          <a:lstStyle/>
+          <a:p>
+            <a:r>
+              <a:t>0:00–0:45 — WELCOME. Say: 'Thank you for being here. My name is Jessica Alvarez, and I am the owner and advocate at Southern Oak Financial and Wellness. In the next fifteen minutes I am going to show you exactly what we do, how we provide it, and what you will get — with every price up front. There are no surprises with us, and there is never any pressure.' Keep it warm and slow. This meeting is free.</a:t>
+            </a:r>
+          </a:p>
+        </p:txBody>
+      </p:sp>
+      <p:sp>
+        <p:nvSpPr>
+          <p:cNvPr id="4" name="Slide Number Placeholder 3"/>
+          <p:cNvSpPr>
+            <a:spLocks noGrp="1"/>
+          </p:cNvSpPr>
+          <p:nvPr>
+            <p:ph type="sldNum" idx="5" sz="quarter"/>
+          </p:nvPr>
+        </p:nvSpPr>
+        <p:spPr/>
+      </p:sp>
+    </p:spTree>
+  </p:cSld>
+  <p:clrMapOvr>
+    <a:masterClrMapping/>
+  </p:clrMapOvr>
+</p:notes>
+</file>
+
+<file path=ppt/notesSlides/notesSlide10.xml><?xml version="1.0" encoding="utf-8"?>
+<p:notes xmlns:a="http://schemas.openxmlformats.org/drawingml/2006/main" xmlns:p="http://schemas.openxmlformats.org/presentationml/2006/main" xmlns:r="http://schemas.openxmlformats.org/officeDocument/2006/relationships">
+  <p:cSld>
+    <p:spTree>
+      <p:nvGrpSpPr>
+        <p:cNvPr id="1" name=""/>
+        <p:cNvGrpSpPr/>
+        <p:nvPr/>
+      </p:nvGrpSpPr>
+      <p:grpSpPr>
+        <a:xfrm>
+          <a:off x="0" y="0"/>
+          <a:ext cx="0" cy="0"/>
+          <a:chOff x="0" y="0"/>
+          <a:chExt cx="0" cy="0"/>
+        </a:xfrm>
+      </p:grpSpPr>
+      <p:sp>
+        <p:nvSpPr>
+          <p:cNvPr id="2" name="Slide Image Placeholder 1"/>
+          <p:cNvSpPr>
+            <a:spLocks noGrp="1"/>
+          </p:cNvSpPr>
+          <p:nvPr>
+            <p:ph type="sldImg" idx="2"/>
+          </p:nvPr>
+        </p:nvSpPr>
+        <p:spPr/>
+      </p:sp>
+      <p:sp>
+        <p:nvSpPr>
+          <p:cNvPr id="3" name="Notes Placeholder 2"/>
+          <p:cNvSpPr>
+            <a:spLocks noGrp="1"/>
+          </p:cNvSpPr>
+          <p:nvPr>
+            <p:ph type="body" idx="3" sz="quarter"/>
+          </p:nvPr>
+        </p:nvSpPr>
+        <p:spPr/>
+        <p:txBody>
+          <a:bodyPr/>
+          <a:lstStyle/>
+          <a:p>
+            <a:r>
+              <a:t>10:15–11:15 — SSA FILING HELP. Be clear this is separate help, not a package. Say: 'If all you need is help filing, that is fifty dollars, paid in full. I give you the steps, YOU file it yourself — it is your case, your signature — and I am on Zoom guiding you, up to four hours, until the filing is done. If we need more time, it is ten dollars for every extra thirty minutes, and only for the time we use. And if Social Security says no — email me right away. Deadlines matter, and I will connect you with special needs attorneys who charge nothing up front.' Also prepare them for what comes after the filing: 'Social Security will mail you letters — open every one. If they schedule an exam, Social Security pays for it, not you. And write your Reference Number down and send it to me — that number is how we get back into your case.' Families panic at the letters; warning them here turns panic into a plan.</a:t>
+            </a:r>
+          </a:p>
+        </p:txBody>
+      </p:sp>
+      <p:sp>
+        <p:nvSpPr>
+          <p:cNvPr id="4" name="Slide Number Placeholder 3"/>
+          <p:cNvSpPr>
+            <a:spLocks noGrp="1"/>
+          </p:cNvSpPr>
+          <p:nvPr>
+            <p:ph type="sldNum" idx="5" sz="quarter"/>
+          </p:nvPr>
+        </p:nvSpPr>
+        <p:spPr/>
+      </p:sp>
+    </p:spTree>
+  </p:cSld>
+  <p:clrMapOvr>
+    <a:masterClrMapping/>
+  </p:clrMapOvr>
+</p:notes>
+</file>
+
+<file path=ppt/notesSlides/notesSlide11.xml><?xml version="1.0" encoding="utf-8"?>
+<p:notes xmlns:a="http://schemas.openxmlformats.org/drawingml/2006/main" xmlns:p="http://schemas.openxmlformats.org/presentationml/2006/main" xmlns:r="http://schemas.openxmlformats.org/officeDocument/2006/relationships">
+  <p:cSld>
+    <p:spTree>
+      <p:nvGrpSpPr>
+        <p:cNvPr id="1" name=""/>
+        <p:cNvGrpSpPr/>
+        <p:nvPr/>
+      </p:nvGrpSpPr>
+      <p:grpSpPr>
+        <a:xfrm>
+          <a:off x="0" y="0"/>
+          <a:ext cx="0" cy="0"/>
+          <a:chOff x="0" y="0"/>
+          <a:chExt cx="0" cy="0"/>
+        </a:xfrm>
+      </p:grpSpPr>
+      <p:sp>
+        <p:nvSpPr>
+          <p:cNvPr id="2" name="Slide Image Placeholder 1"/>
+          <p:cNvSpPr>
+            <a:spLocks noGrp="1"/>
+          </p:cNvSpPr>
+          <p:nvPr>
+            <p:ph type="sldImg" idx="2"/>
+          </p:nvPr>
+        </p:nvSpPr>
+        <p:spPr/>
+      </p:sp>
+      <p:sp>
+        <p:nvSpPr>
+          <p:cNvPr id="3" name="Notes Placeholder 2"/>
+          <p:cNvSpPr>
+            <a:spLocks noGrp="1"/>
+          </p:cNvSpPr>
+          <p:nvPr>
+            <p:ph type="body" idx="3" sz="quarter"/>
+          </p:nvPr>
+        </p:nvSpPr>
+        <p:spPr/>
+        <p:txBody>
+          <a:bodyPr/>
+          <a:lstStyle/>
+          <a:p>
+            <a:r>
+              <a:t>11:15–12:00 — CREDIT. Say: 'For credit, we start with the truth: a full analysis of your reports, in simple words — what is hurting you and why. That, with your first dispute prepared, is one hundred fifty dollars, paid in full. You sign your own letters — always. If you need more rounds after that, it is eighty-nine a month, cancel anytime. And we build your budget with it, because fixing credit without a budget is like mopping with the water running.'</a:t>
+            </a:r>
+          </a:p>
+        </p:txBody>
+      </p:sp>
+      <p:sp>
+        <p:nvSpPr>
+          <p:cNvPr id="4" name="Slide Number Placeholder 3"/>
+          <p:cNvSpPr>
+            <a:spLocks noGrp="1"/>
+          </p:cNvSpPr>
+          <p:nvPr>
+            <p:ph type="sldNum" idx="5" sz="quarter"/>
+          </p:nvPr>
+        </p:nvSpPr>
+        <p:spPr/>
+      </p:sp>
+    </p:spTree>
+  </p:cSld>
+  <p:clrMapOvr>
+    <a:masterClrMapping/>
+  </p:clrMapOvr>
+</p:notes>
+</file>
+
+<file path=ppt/notesSlides/notesSlide12.xml><?xml version="1.0" encoding="utf-8"?>
+<p:notes xmlns:a="http://schemas.openxmlformats.org/drawingml/2006/main" xmlns:p="http://schemas.openxmlformats.org/presentationml/2006/main" xmlns:r="http://schemas.openxmlformats.org/officeDocument/2006/relationships">
+  <p:cSld>
+    <p:spTree>
+      <p:nvGrpSpPr>
+        <p:cNvPr id="1" name=""/>
+        <p:cNvGrpSpPr/>
+        <p:nvPr/>
+      </p:nvGrpSpPr>
+      <p:grpSpPr>
+        <a:xfrm>
+          <a:off x="0" y="0"/>
+          <a:ext cx="0" cy="0"/>
+          <a:chOff x="0" y="0"/>
+          <a:chExt cx="0" cy="0"/>
+        </a:xfrm>
+      </p:grpSpPr>
+      <p:sp>
+        <p:nvSpPr>
+          <p:cNvPr id="2" name="Slide Image Placeholder 1"/>
+          <p:cNvSpPr>
+            <a:spLocks noGrp="1"/>
+          </p:cNvSpPr>
+          <p:nvPr>
+            <p:ph type="sldImg" idx="2"/>
+          </p:nvPr>
+        </p:nvSpPr>
+        <p:spPr/>
+      </p:sp>
+      <p:sp>
+        <p:nvSpPr>
+          <p:cNvPr id="3" name="Notes Placeholder 2"/>
+          <p:cNvSpPr>
+            <a:spLocks noGrp="1"/>
+          </p:cNvSpPr>
+          <p:nvPr>
+            <p:ph type="body" idx="3" sz="quarter"/>
+          </p:nvPr>
+        </p:nvSpPr>
+        <p:spPr/>
+        <p:txBody>
+          <a:bodyPr/>
+          <a:lstStyle/>
+          <a:p>
+            <a:r>
+              <a:t>12:00–12:45 — THE FREE STARTS. Say: 'Two things are always free to start. One: bring me your medication list. We check the discount programs and the maker programs for every single medicine — and if your medicine is on our assistance list, the forms are free. Two: the protection talk. We look at what your family would need if something happened to you. I never charge for that conversation — you pay nothing unless you approve a policy.'</a:t>
+            </a:r>
+          </a:p>
+        </p:txBody>
+      </p:sp>
+      <p:sp>
+        <p:nvSpPr>
+          <p:cNvPr id="4" name="Slide Number Placeholder 3"/>
+          <p:cNvSpPr>
+            <a:spLocks noGrp="1"/>
+          </p:cNvSpPr>
+          <p:nvPr>
+            <p:ph type="sldNum" idx="5" sz="quarter"/>
+          </p:nvPr>
+        </p:nvSpPr>
+        <p:spPr/>
+      </p:sp>
+    </p:spTree>
+  </p:cSld>
+  <p:clrMapOvr>
+    <a:masterClrMapping/>
+  </p:clrMapOvr>
+</p:notes>
+</file>
+
+<file path=ppt/notesSlides/notesSlide13.xml><?xml version="1.0" encoding="utf-8"?>
+<p:notes xmlns:a="http://schemas.openxmlformats.org/drawingml/2006/main" xmlns:p="http://schemas.openxmlformats.org/presentationml/2006/main" xmlns:r="http://schemas.openxmlformats.org/officeDocument/2006/relationships">
+  <p:cSld>
+    <p:spTree>
+      <p:nvGrpSpPr>
+        <p:cNvPr id="1" name=""/>
+        <p:cNvGrpSpPr/>
+        <p:nvPr/>
+      </p:nvGrpSpPr>
+      <p:grpSpPr>
+        <a:xfrm>
+          <a:off x="0" y="0"/>
+          <a:ext cx="0" cy="0"/>
+          <a:chOff x="0" y="0"/>
+          <a:chExt cx="0" cy="0"/>
+        </a:xfrm>
+      </p:grpSpPr>
+      <p:sp>
+        <p:nvSpPr>
+          <p:cNvPr id="2" name="Slide Image Placeholder 1"/>
+          <p:cNvSpPr>
+            <a:spLocks noGrp="1"/>
+          </p:cNvSpPr>
+          <p:nvPr>
+            <p:ph type="sldImg" idx="2"/>
+          </p:nvPr>
+        </p:nvSpPr>
+        <p:spPr/>
+      </p:sp>
+      <p:sp>
+        <p:nvSpPr>
+          <p:cNvPr id="3" name="Notes Placeholder 2"/>
+          <p:cNvSpPr>
+            <a:spLocks noGrp="1"/>
+          </p:cNvSpPr>
+          <p:nvPr>
+            <p:ph type="body" idx="3" sz="quarter"/>
+          </p:nvPr>
+        </p:nvSpPr>
+        <p:spPr/>
+        <p:txBody>
+          <a:bodyPr/>
+          <a:lstStyle/>
+          <a:p>
+            <a:r>
+              <a:t>12:45–13:15 — GUIDANCE. Say: 'And whenever you get stuck — with your plan, with a letter, with a form — you can book one guidance Zoom at a time. Twenty-six dollars for thirty minutes. You book it only when you need it. You never pay for help sitting unused.'</a:t>
+            </a:r>
+          </a:p>
+        </p:txBody>
+      </p:sp>
+      <p:sp>
+        <p:nvSpPr>
+          <p:cNvPr id="4" name="Slide Number Placeholder 3"/>
+          <p:cNvSpPr>
+            <a:spLocks noGrp="1"/>
+          </p:cNvSpPr>
+          <p:nvPr>
+            <p:ph type="sldNum" idx="5" sz="quarter"/>
+          </p:nvPr>
+        </p:nvSpPr>
+        <p:spPr/>
+      </p:sp>
+    </p:spTree>
+  </p:cSld>
+  <p:clrMapOvr>
+    <a:masterClrMapping/>
+  </p:clrMapOvr>
+</p:notes>
+</file>
+
+<file path=ppt/notesSlides/notesSlide14.xml><?xml version="1.0" encoding="utf-8"?>
+<p:notes xmlns:a="http://schemas.openxmlformats.org/drawingml/2006/main" xmlns:p="http://schemas.openxmlformats.org/presentationml/2006/main" xmlns:r="http://schemas.openxmlformats.org/officeDocument/2006/relationships">
+  <p:cSld>
+    <p:spTree>
+      <p:nvGrpSpPr>
+        <p:cNvPr id="1" name=""/>
+        <p:cNvGrpSpPr/>
+        <p:nvPr/>
+      </p:nvGrpSpPr>
+      <p:grpSpPr>
+        <a:xfrm>
+          <a:off x="0" y="0"/>
+          <a:ext cx="0" cy="0"/>
+          <a:chOff x="0" y="0"/>
+          <a:chExt cx="0" cy="0"/>
+        </a:xfrm>
+      </p:grpSpPr>
+      <p:sp>
+        <p:nvSpPr>
+          <p:cNvPr id="2" name="Slide Image Placeholder 1"/>
+          <p:cNvSpPr>
+            <a:spLocks noGrp="1"/>
+          </p:cNvSpPr>
+          <p:nvPr>
+            <p:ph type="sldImg" idx="2"/>
+          </p:nvPr>
+        </p:nvSpPr>
+        <p:spPr/>
+      </p:sp>
+      <p:sp>
+        <p:nvSpPr>
+          <p:cNvPr id="3" name="Notes Placeholder 2"/>
+          <p:cNvSpPr>
+            <a:spLocks noGrp="1"/>
+          </p:cNvSpPr>
+          <p:nvPr>
+            <p:ph type="body" idx="3" sz="quarter"/>
+          </p:nvPr>
+        </p:nvSpPr>
+        <p:spPr/>
+        <p:txBody>
+          <a:bodyPr/>
+          <a:lstStyle/>
+          <a:p>
+            <a:r>
+              <a:t>13:15–14:00 — PRICES. Say it plainly, all of it, and pause: 'Here is everything, on one slide. The consultation and your results are free. We have ONE package — the Plan Package, three ninety-nine, half and half. Everything else is separate help, only if you need it: filing help fifty, credit analysis one fifty, guidance twenty-six. Nothing is hidden, and nothing gets added later.'</a:t>
+            </a:r>
+          </a:p>
+        </p:txBody>
+      </p:sp>
+      <p:sp>
+        <p:nvSpPr>
+          <p:cNvPr id="4" name="Slide Number Placeholder 3"/>
+          <p:cNvSpPr>
+            <a:spLocks noGrp="1"/>
+          </p:cNvSpPr>
+          <p:nvPr>
+            <p:ph type="sldNum" idx="5" sz="quarter"/>
+          </p:nvPr>
+        </p:nvSpPr>
+        <p:spPr/>
+      </p:sp>
+    </p:spTree>
+  </p:cSld>
+  <p:clrMapOvr>
+    <a:masterClrMapping/>
+  </p:clrMapOvr>
+</p:notes>
+</file>
+
+<file path=ppt/notesSlides/notesSlide15.xml><?xml version="1.0" encoding="utf-8"?>
+<p:notes xmlns:a="http://schemas.openxmlformats.org/drawingml/2006/main" xmlns:p="http://schemas.openxmlformats.org/presentationml/2006/main" xmlns:r="http://schemas.openxmlformats.org/officeDocument/2006/relationships">
+  <p:cSld>
+    <p:spTree>
+      <p:nvGrpSpPr>
+        <p:cNvPr id="1" name=""/>
+        <p:cNvGrpSpPr/>
+        <p:nvPr/>
+      </p:nvGrpSpPr>
+      <p:grpSpPr>
+        <a:xfrm>
+          <a:off x="0" y="0"/>
+          <a:ext cx="0" cy="0"/>
+          <a:chOff x="0" y="0"/>
+          <a:chExt cx="0" cy="0"/>
+        </a:xfrm>
+      </p:grpSpPr>
+      <p:sp>
+        <p:nvSpPr>
+          <p:cNvPr id="2" name="Slide Image Placeholder 1"/>
+          <p:cNvSpPr>
+            <a:spLocks noGrp="1"/>
+          </p:cNvSpPr>
+          <p:nvPr>
+            <p:ph type="sldImg" idx="2"/>
+          </p:nvPr>
+        </p:nvSpPr>
+        <p:spPr/>
+      </p:sp>
+      <p:sp>
+        <p:nvSpPr>
+          <p:cNvPr id="3" name="Notes Placeholder 2"/>
+          <p:cNvSpPr>
+            <a:spLocks noGrp="1"/>
+          </p:cNvSpPr>
+          <p:nvPr>
+            <p:ph type="body" idx="3" sz="quarter"/>
+          </p:nvPr>
+        </p:nvSpPr>
+        <p:spPr/>
+        <p:txBody>
+          <a:bodyPr/>
+          <a:lstStyle/>
+          <a:p>
+            <a:r>
+              <a:t>14:00–14:45 — QUESTIONS. Open it up gently: 'Before we finish — questions. And let me ask you one: what worries you most right now? Whatever it is, that is probably where your plan starts.' Listen more than you talk in this part. If they are quiet, that is fine — do not fill the silence with selling.</a:t>
+            </a:r>
+          </a:p>
+        </p:txBody>
+      </p:sp>
+      <p:sp>
+        <p:nvSpPr>
+          <p:cNvPr id="4" name="Slide Number Placeholder 3"/>
+          <p:cNvSpPr>
+            <a:spLocks noGrp="1"/>
+          </p:cNvSpPr>
+          <p:nvPr>
+            <p:ph type="sldNum" idx="5" sz="quarter"/>
+          </p:nvPr>
+        </p:nvSpPr>
+        <p:spPr/>
+      </p:sp>
+    </p:spTree>
+  </p:cSld>
+  <p:clrMapOvr>
+    <a:masterClrMapping/>
+  </p:clrMapOvr>
+</p:notes>
+</file>
+
+<file path=ppt/notesSlides/notesSlide16.xml><?xml version="1.0" encoding="utf-8"?>
+<p:notes xmlns:a="http://schemas.openxmlformats.org/drawingml/2006/main" xmlns:p="http://schemas.openxmlformats.org/presentationml/2006/main" xmlns:r="http://schemas.openxmlformats.org/officeDocument/2006/relationships">
+  <p:cSld>
+    <p:spTree>
+      <p:nvGrpSpPr>
+        <p:cNvPr id="1" name=""/>
+        <p:cNvGrpSpPr/>
+        <p:nvPr/>
+      </p:nvGrpSpPr>
+      <p:grpSpPr>
+        <a:xfrm>
+          <a:off x="0" y="0"/>
+          <a:ext cx="0" cy="0"/>
+          <a:chOff x="0" y="0"/>
+          <a:chExt cx="0" cy="0"/>
+        </a:xfrm>
+      </p:grpSpPr>
+      <p:sp>
+        <p:nvSpPr>
+          <p:cNvPr id="2" name="Slide Image Placeholder 1"/>
+          <p:cNvSpPr>
+            <a:spLocks noGrp="1"/>
+          </p:cNvSpPr>
+          <p:nvPr>
+            <p:ph type="sldImg" idx="2"/>
+          </p:nvPr>
+        </p:nvSpPr>
+        <p:spPr/>
+      </p:sp>
+      <p:sp>
+        <p:nvSpPr>
+          <p:cNvPr id="3" name="Notes Placeholder 2"/>
+          <p:cNvSpPr>
+            <a:spLocks noGrp="1"/>
+          </p:cNvSpPr>
+          <p:nvPr>
+            <p:ph type="body" idx="3" sz="quarter"/>
+          </p:nvPr>
+        </p:nvSpPr>
+        <p:spPr/>
+        <p:txBody>
+          <a:bodyPr/>
+          <a:lstStyle/>
+          <a:p>
+            <a:r>
+              <a:t>14:45–15:00 — CLOSE. Say: 'Here is what happens next. I send your results page by email. You take your time — talk it over at home. When you are ready, email me, and we start together, step by step. Thank you for trusting me with your family's time today. No family should do this alone — and yours does not have to.' End on time. Fifteen minutes, as promised.</a:t>
+            </a:r>
+          </a:p>
+        </p:txBody>
+      </p:sp>
+      <p:sp>
+        <p:nvSpPr>
+          <p:cNvPr id="4" name="Slide Number Placeholder 3"/>
+          <p:cNvSpPr>
+            <a:spLocks noGrp="1"/>
+          </p:cNvSpPr>
+          <p:nvPr>
+            <p:ph type="sldNum" idx="5" sz="quarter"/>
+          </p:nvPr>
+        </p:nvSpPr>
+        <p:spPr/>
+      </p:sp>
+    </p:spTree>
+  </p:cSld>
+  <p:clrMapOvr>
+    <a:masterClrMapping/>
+  </p:clrMapOvr>
+</p:notes>
+</file>
+
+<file path=ppt/notesSlides/notesSlide2.xml><?xml version="1.0" encoding="utf-8"?>
+<p:notes xmlns:a="http://schemas.openxmlformats.org/drawingml/2006/main" xmlns:p="http://schemas.openxmlformats.org/presentationml/2006/main" xmlns:r="http://schemas.openxmlformats.org/officeDocument/2006/relationships">
+  <p:cSld>
+    <p:spTree>
+      <p:nvGrpSpPr>
+        <p:cNvPr id="1" name=""/>
+        <p:cNvGrpSpPr/>
+        <p:nvPr/>
+      </p:nvGrpSpPr>
+      <p:grpSpPr>
+        <a:xfrm>
+          <a:off x="0" y="0"/>
+          <a:ext cx="0" cy="0"/>
+          <a:chOff x="0" y="0"/>
+          <a:chExt cx="0" cy="0"/>
+        </a:xfrm>
+      </p:grpSpPr>
+      <p:sp>
+        <p:nvSpPr>
+          <p:cNvPr id="2" name="Slide Image Placeholder 1"/>
+          <p:cNvSpPr>
+            <a:spLocks noGrp="1"/>
+          </p:cNvSpPr>
+          <p:nvPr>
+            <p:ph type="sldImg" idx="2"/>
+          </p:nvPr>
+        </p:nvSpPr>
+        <p:spPr/>
+      </p:sp>
+      <p:sp>
+        <p:nvSpPr>
+          <p:cNvPr id="3" name="Notes Placeholder 2"/>
+          <p:cNvSpPr>
+            <a:spLocks noGrp="1"/>
+          </p:cNvSpPr>
+          <p:nvPr>
+            <p:ph type="body" idx="3" sz="quarter"/>
+          </p:nvPr>
+        </p:nvSpPr>
+        <p:spPr/>
+        <p:txBody>
+          <a:bodyPr/>
+          <a:lstStyle/>
+          <a:p>
+            <a:r>
+              <a:t>0:45–2:00 — YOUR STORY. Say: 'I have worked with the special needs community for five years, and I have been a life insurance agent for four. But the real reason I do this is personal. When I was eleven, I was diagnosed with juvenile rheumatoid arthritis. I watched my parents struggle — with Social Security, with medication costs, with finding help. Nobody should have to figure that out alone, at the hardest time of their life. So I built Southern Oak to be the help my family needed back then.' Pause here. This is the heart of the whole presentation. If a family member is with them, include them: 'Everything I help with touches the whole family — the benefits, the budget, the protection — so I am glad you are both here.' If the consultation is for their child, say the child's name here. Using their child's name early builds trust for everything after.</a:t>
+            </a:r>
+          </a:p>
+        </p:txBody>
+      </p:sp>
+      <p:sp>
+        <p:nvSpPr>
+          <p:cNvPr id="4" name="Slide Number Placeholder 3"/>
+          <p:cNvSpPr>
+            <a:spLocks noGrp="1"/>
+          </p:cNvSpPr>
+          <p:nvPr>
+            <p:ph type="sldNum" idx="5" sz="quarter"/>
+          </p:nvPr>
+        </p:nvSpPr>
+        <p:spPr/>
+      </p:sp>
+    </p:spTree>
+  </p:cSld>
+  <p:clrMapOvr>
+    <a:masterClrMapping/>
+  </p:clrMapOvr>
+</p:notes>
+</file>
+
+<file path=ppt/notesSlides/notesSlide3.xml><?xml version="1.0" encoding="utf-8"?>
+<p:notes xmlns:a="http://schemas.openxmlformats.org/drawingml/2006/main" xmlns:p="http://schemas.openxmlformats.org/presentationml/2006/main" xmlns:r="http://schemas.openxmlformats.org/officeDocument/2006/relationships">
+  <p:cSld>
+    <p:spTree>
+      <p:nvGrpSpPr>
+        <p:cNvPr id="1" name=""/>
+        <p:cNvGrpSpPr/>
+        <p:nvPr/>
+      </p:nvGrpSpPr>
+      <p:grpSpPr>
+        <a:xfrm>
+          <a:off x="0" y="0"/>
+          <a:ext cx="0" cy="0"/>
+          <a:chOff x="0" y="0"/>
+          <a:chExt cx="0" cy="0"/>
+        </a:xfrm>
+      </p:grpSpPr>
+      <p:sp>
+        <p:nvSpPr>
+          <p:cNvPr id="2" name="Slide Image Placeholder 1"/>
+          <p:cNvSpPr>
+            <a:spLocks noGrp="1"/>
+          </p:cNvSpPr>
+          <p:nvPr>
+            <p:ph type="sldImg" idx="2"/>
+          </p:nvPr>
+        </p:nvSpPr>
+        <p:spPr/>
+      </p:sp>
+      <p:sp>
+        <p:nvSpPr>
+          <p:cNvPr id="3" name="Notes Placeholder 2"/>
+          <p:cNvSpPr>
+            <a:spLocks noGrp="1"/>
+          </p:cNvSpPr>
+          <p:nvPr>
+            <p:ph type="body" idx="3" sz="quarter"/>
+          </p:nvPr>
+        </p:nvSpPr>
+        <p:spPr/>
+        <p:txBody>
+          <a:bodyPr/>
+          <a:lstStyle/>
+          <a:p>
+            <a:r>
+              <a:t>2:00–3:00 — THE FIVE WAYS. Walk each one with one sentence. SSA: 'We help you apply for SSI or SSDI — for your child, or for you.' Insurance: 'Protection that can help while you are living, and after you are gone.' Medication: 'A free check — many families pay less within the first month.' Credit: 'A budget that fits real life, and we fix what is wrong on your reports.' Transition: 'When a child turns eighteen, the rules change — we get families ready before the birthday, not after.'</a:t>
+            </a:r>
+          </a:p>
+        </p:txBody>
+      </p:sp>
+      <p:sp>
+        <p:nvSpPr>
+          <p:cNvPr id="4" name="Slide Number Placeholder 3"/>
+          <p:cNvSpPr>
+            <a:spLocks noGrp="1"/>
+          </p:cNvSpPr>
+          <p:nvPr>
+            <p:ph type="sldNum" idx="5" sz="quarter"/>
+          </p:nvPr>
+        </p:nvSpPr>
+        <p:spPr/>
+      </p:sp>
+    </p:spTree>
+  </p:cSld>
+  <p:clrMapOvr>
+    <a:masterClrMapping/>
+  </p:clrMapOvr>
+</p:notes>
+</file>
+
+<file path=ppt/notesSlides/notesSlide4.xml><?xml version="1.0" encoding="utf-8"?>
+<p:notes xmlns:a="http://schemas.openxmlformats.org/drawingml/2006/main" xmlns:p="http://schemas.openxmlformats.org/presentationml/2006/main" xmlns:r="http://schemas.openxmlformats.org/officeDocument/2006/relationships">
+  <p:cSld>
+    <p:spTree>
+      <p:nvGrpSpPr>
+        <p:cNvPr id="1" name=""/>
+        <p:cNvGrpSpPr/>
+        <p:nvPr/>
+      </p:nvGrpSpPr>
+      <p:grpSpPr>
+        <a:xfrm>
+          <a:off x="0" y="0"/>
+          <a:ext cx="0" cy="0"/>
+          <a:chOff x="0" y="0"/>
+          <a:chExt cx="0" cy="0"/>
+        </a:xfrm>
+      </p:grpSpPr>
+      <p:sp>
+        <p:nvSpPr>
+          <p:cNvPr id="2" name="Slide Image Placeholder 1"/>
+          <p:cNvSpPr>
+            <a:spLocks noGrp="1"/>
+          </p:cNvSpPr>
+          <p:nvPr>
+            <p:ph type="sldImg" idx="2"/>
+          </p:nvPr>
+        </p:nvSpPr>
+        <p:spPr/>
+      </p:sp>
+      <p:sp>
+        <p:nvSpPr>
+          <p:cNvPr id="3" name="Notes Placeholder 2"/>
+          <p:cNvSpPr>
+            <a:spLocks noGrp="1"/>
+          </p:cNvSpPr>
+          <p:nvPr>
+            <p:ph type="body" idx="3" sz="quarter"/>
+          </p:nvPr>
+        </p:nvSpPr>
+        <p:spPr/>
+        <p:txBody>
+          <a:bodyPr/>
+          <a:lstStyle/>
+          <a:p>
+            <a:r>
+              <a:t>3:00–4:15 — THE ROAD. Say: 'Everything starts with a free consultation, like this one. Before we meet, you fill out a short intake online. Then I review your whole picture myself — not a computer, me. And you get a results page, free, that is yours to keep even if we never work together again. From there, YOU choose how we help. Nothing starts until you say so.'</a:t>
+            </a:r>
+          </a:p>
+        </p:txBody>
+      </p:sp>
+      <p:sp>
+        <p:nvSpPr>
+          <p:cNvPr id="4" name="Slide Number Placeholder 3"/>
+          <p:cNvSpPr>
+            <a:spLocks noGrp="1"/>
+          </p:cNvSpPr>
+          <p:nvPr>
+            <p:ph type="sldNum" idx="5" sz="quarter"/>
+          </p:nvPr>
+        </p:nvSpPr>
+        <p:spPr/>
+      </p:sp>
+    </p:spTree>
+  </p:cSld>
+  <p:clrMapOvr>
+    <a:masterClrMapping/>
+  </p:clrMapOvr>
+</p:notes>
+</file>
+
+<file path=ppt/notesSlides/notesSlide5.xml><?xml version="1.0" encoding="utf-8"?>
+<p:notes xmlns:a="http://schemas.openxmlformats.org/drawingml/2006/main" xmlns:p="http://schemas.openxmlformats.org/presentationml/2006/main" xmlns:r="http://schemas.openxmlformats.org/officeDocument/2006/relationships">
+  <p:cSld>
+    <p:spTree>
+      <p:nvGrpSpPr>
+        <p:cNvPr id="1" name=""/>
+        <p:cNvGrpSpPr/>
+        <p:nvPr/>
+      </p:nvGrpSpPr>
+      <p:grpSpPr>
+        <a:xfrm>
+          <a:off x="0" y="0"/>
+          <a:ext cx="0" cy="0"/>
+          <a:chOff x="0" y="0"/>
+          <a:chExt cx="0" cy="0"/>
+        </a:xfrm>
+      </p:grpSpPr>
+      <p:sp>
+        <p:nvSpPr>
+          <p:cNvPr id="2" name="Slide Image Placeholder 1"/>
+          <p:cNvSpPr>
+            <a:spLocks noGrp="1"/>
+          </p:cNvSpPr>
+          <p:nvPr>
+            <p:ph type="sldImg" idx="2"/>
+          </p:nvPr>
+        </p:nvSpPr>
+        <p:spPr/>
+      </p:sp>
+      <p:sp>
+        <p:nvSpPr>
+          <p:cNvPr id="3" name="Notes Placeholder 2"/>
+          <p:cNvSpPr>
+            <a:spLocks noGrp="1"/>
+          </p:cNvSpPr>
+          <p:nvPr>
+            <p:ph type="body" idx="3" sz="quarter"/>
+          </p:nvPr>
+        </p:nvSpPr>
+        <p:spPr/>
+        <p:txBody>
+          <a:bodyPr/>
+          <a:lstStyle/>
+          <a:p>
+            <a:r>
+              <a:t>4:15–5:30 — THE REVIEW. Say: 'When I review your family, I look at six things.' Name each one and give a tiny example: a denial letter with a deadline nobody saw; a medicine that costs ninety dollars that could cost nine; a parent with no coverage at all; a young adult three months from eighteen with no papers started. Examples make families see their own life in the list. One more thing to name out loud: the road to eighteen. Say: 'And if your child is anywhere near eighteen, tell me today — that birthday changes how Social Security decides, and the papers for it take time, not days.' Many parents do not know the rules change at eighteen. The moment they learn it from you, you become the person they call first.</a:t>
+            </a:r>
+          </a:p>
+        </p:txBody>
+      </p:sp>
+      <p:sp>
+        <p:nvSpPr>
+          <p:cNvPr id="4" name="Slide Number Placeholder 3"/>
+          <p:cNvSpPr>
+            <a:spLocks noGrp="1"/>
+          </p:cNvSpPr>
+          <p:nvPr>
+            <p:ph type="sldNum" idx="5" sz="quarter"/>
+          </p:nvPr>
+        </p:nvSpPr>
+        <p:spPr/>
+      </p:sp>
+    </p:spTree>
+  </p:cSld>
+  <p:clrMapOvr>
+    <a:masterClrMapping/>
+  </p:clrMapOvr>
+</p:notes>
+</file>
+
+<file path=ppt/notesSlides/notesSlide6.xml><?xml version="1.0" encoding="utf-8"?>
+<p:notes xmlns:a="http://schemas.openxmlformats.org/drawingml/2006/main" xmlns:p="http://schemas.openxmlformats.org/presentationml/2006/main" xmlns:r="http://schemas.openxmlformats.org/officeDocument/2006/relationships">
+  <p:cSld>
+    <p:spTree>
+      <p:nvGrpSpPr>
+        <p:cNvPr id="1" name=""/>
+        <p:cNvGrpSpPr/>
+        <p:nvPr/>
+      </p:nvGrpSpPr>
+      <p:grpSpPr>
+        <a:xfrm>
+          <a:off x="0" y="0"/>
+          <a:ext cx="0" cy="0"/>
+          <a:chOff x="0" y="0"/>
+          <a:chExt cx="0" cy="0"/>
+        </a:xfrm>
+      </p:grpSpPr>
+      <p:sp>
+        <p:nvSpPr>
+          <p:cNvPr id="2" name="Slide Image Placeholder 1"/>
+          <p:cNvSpPr>
+            <a:spLocks noGrp="1"/>
+          </p:cNvSpPr>
+          <p:nvPr>
+            <p:ph type="sldImg" idx="2"/>
+          </p:nvPr>
+        </p:nvSpPr>
+        <p:spPr/>
+      </p:sp>
+      <p:sp>
+        <p:nvSpPr>
+          <p:cNvPr id="3" name="Notes Placeholder 2"/>
+          <p:cNvSpPr>
+            <a:spLocks noGrp="1"/>
+          </p:cNvSpPr>
+          <p:nvPr>
+            <p:ph type="body" idx="3" sz="quarter"/>
+          </p:nvPr>
+        </p:nvSpPr>
+        <p:spPr/>
+        <p:txBody>
+          <a:bodyPr/>
+          <a:lstStyle/>
+          <a:p>
+            <a:r>
+              <a:t>5:30–6:15 — THE RESULTS. Say: 'After our meeting, I send you your results page by email. It shows where you are, what you need, and your first steps in order — one, two, three. If I recommend something, the price is written right on the page. Take your time with it. Talk it over at home. It is yours to keep, free, no matter what you decide.'</a:t>
+            </a:r>
+          </a:p>
+        </p:txBody>
+      </p:sp>
+      <p:sp>
+        <p:nvSpPr>
+          <p:cNvPr id="4" name="Slide Number Placeholder 3"/>
+          <p:cNvSpPr>
+            <a:spLocks noGrp="1"/>
+          </p:cNvSpPr>
+          <p:nvPr>
+            <p:ph type="sldNum" idx="5" sz="quarter"/>
+          </p:nvPr>
+        </p:nvSpPr>
+        <p:spPr/>
+      </p:sp>
+    </p:spTree>
+  </p:cSld>
+  <p:clrMapOvr>
+    <a:masterClrMapping/>
+  </p:clrMapOvr>
+</p:notes>
+</file>
+
+<file path=ppt/notesSlides/notesSlide7.xml><?xml version="1.0" encoding="utf-8"?>
+<p:notes xmlns:a="http://schemas.openxmlformats.org/drawingml/2006/main" xmlns:p="http://schemas.openxmlformats.org/presentationml/2006/main" xmlns:r="http://schemas.openxmlformats.org/officeDocument/2006/relationships">
+  <p:cSld>
+    <p:spTree>
+      <p:nvGrpSpPr>
+        <p:cNvPr id="1" name=""/>
+        <p:cNvGrpSpPr/>
+        <p:nvPr/>
+      </p:nvGrpSpPr>
+      <p:grpSpPr>
+        <a:xfrm>
+          <a:off x="0" y="0"/>
+          <a:ext cx="0" cy="0"/>
+          <a:chOff x="0" y="0"/>
+          <a:chExt cx="0" cy="0"/>
+        </a:xfrm>
+      </p:grpSpPr>
+      <p:sp>
+        <p:nvSpPr>
+          <p:cNvPr id="2" name="Slide Image Placeholder 1"/>
+          <p:cNvSpPr>
+            <a:spLocks noGrp="1"/>
+          </p:cNvSpPr>
+          <p:nvPr>
+            <p:ph type="sldImg" idx="2"/>
+          </p:nvPr>
+        </p:nvSpPr>
+        <p:spPr/>
+      </p:sp>
+      <p:sp>
+        <p:nvSpPr>
+          <p:cNvPr id="3" name="Notes Placeholder 2"/>
+          <p:cNvSpPr>
+            <a:spLocks noGrp="1"/>
+          </p:cNvSpPr>
+          <p:nvPr>
+            <p:ph type="body" idx="3" sz="quarter"/>
+          </p:nvPr>
+        </p:nvSpPr>
+        <p:spPr/>
+        <p:txBody>
+          <a:bodyPr/>
+          <a:lstStyle/>
+          <a:p>
+            <a:r>
+              <a:t>6:15–8:15 — THE PACKAGE. This is the center of the presentation — slow down. Say: 'We have ONE package. Just one. I do not believe in levels and tiers for families. The Plan Package is three hundred ninety-nine dollars, one time. I build your whole plan in writing — what to do first, second, third — with every deadline on it. You pay half when you sign, and the second half only before I hand you your plan. Then we go through it together on Zoom, line by line, until your questions are answered. Planning firms charge almost three thousand dollars for this. Ours is built for families like yours — and priced so you can actually have it.' While you are on this slide, be very clear about the two payments: 'The first half is due when you sign the agreement — that is when I start building. The second half is due before I provide the plan. If life happens and the second half has to wait, your plan waits with me, ready — nothing is lost, and there are no late fees or extra charges. When you are ready, we finish.' Say this slowly; it is the part families worry about most.</a:t>
+            </a:r>
+          </a:p>
+        </p:txBody>
+      </p:sp>
+      <p:sp>
+        <p:nvSpPr>
+          <p:cNvPr id="4" name="Slide Number Placeholder 3"/>
+          <p:cNvSpPr>
+            <a:spLocks noGrp="1"/>
+          </p:cNvSpPr>
+          <p:nvPr>
+            <p:ph type="sldNum" idx="5" sz="quarter"/>
+          </p:nvPr>
+        </p:nvSpPr>
+        <p:spPr/>
+      </p:sp>
+    </p:spTree>
+  </p:cSld>
+  <p:clrMapOvr>
+    <a:masterClrMapping/>
+  </p:clrMapOvr>
+</p:notes>
+</file>
+
+<file path=ppt/notesSlides/notesSlide8.xml><?xml version="1.0" encoding="utf-8"?>
+<p:notes xmlns:a="http://schemas.openxmlformats.org/drawingml/2006/main" xmlns:p="http://schemas.openxmlformats.org/presentationml/2006/main" xmlns:r="http://schemas.openxmlformats.org/officeDocument/2006/relationships">
+  <p:cSld>
+    <p:spTree>
+      <p:nvGrpSpPr>
+        <p:cNvPr id="1" name=""/>
+        <p:cNvGrpSpPr/>
+        <p:nvPr/>
+      </p:nvGrpSpPr>
+      <p:grpSpPr>
+        <a:xfrm>
+          <a:off x="0" y="0"/>
+          <a:ext cx="0" cy="0"/>
+          <a:chOff x="0" y="0"/>
+          <a:chExt cx="0" cy="0"/>
+        </a:xfrm>
+      </p:grpSpPr>
+      <p:sp>
+        <p:nvSpPr>
+          <p:cNvPr id="2" name="Slide Image Placeholder 1"/>
+          <p:cNvSpPr>
+            <a:spLocks noGrp="1"/>
+          </p:cNvSpPr>
+          <p:nvPr>
+            <p:ph type="sldImg" idx="2"/>
+          </p:nvPr>
+        </p:nvSpPr>
+        <p:spPr/>
+      </p:sp>
+      <p:sp>
+        <p:nvSpPr>
+          <p:cNvPr id="3" name="Notes Placeholder 2"/>
+          <p:cNvSpPr>
+            <a:spLocks noGrp="1"/>
+          </p:cNvSpPr>
+          <p:nvPr>
+            <p:ph type="body" idx="3" sz="quarter"/>
+          </p:nvPr>
+        </p:nvSpPr>
+        <p:spPr/>
+        <p:txBody>
+          <a:bodyPr/>
+          <a:lstStyle/>
+          <a:p>
+            <a:r>
+              <a:t>8:15–9:15 — THE FAMILY BUILD. Say: 'For a family, the plan looks at everything together — because everything is connected. Your child's benefits affect your budget. Your budget affects your credit. If something happens to you, everything stops — so protection is part of the same plan. Most families I meet are trying to fix five things at once and finishing none. Your plan gives you an order: this first, then this, then this.'</a:t>
+            </a:r>
+          </a:p>
+        </p:txBody>
+      </p:sp>
+      <p:sp>
+        <p:nvSpPr>
+          <p:cNvPr id="4" name="Slide Number Placeholder 3"/>
+          <p:cNvSpPr>
+            <a:spLocks noGrp="1"/>
+          </p:cNvSpPr>
+          <p:nvPr>
+            <p:ph type="sldNum" idx="5" sz="quarter"/>
+          </p:nvPr>
+        </p:nvSpPr>
+        <p:spPr/>
+      </p:sp>
+    </p:spTree>
+  </p:cSld>
+  <p:clrMapOvr>
+    <a:masterClrMapping/>
+  </p:clrMapOvr>
+</p:notes>
+</file>
+
+<file path=ppt/notesSlides/notesSlide9.xml><?xml version="1.0" encoding="utf-8"?>
+<p:notes xmlns:a="http://schemas.openxmlformats.org/drawingml/2006/main" xmlns:p="http://schemas.openxmlformats.org/presentationml/2006/main" xmlns:r="http://schemas.openxmlformats.org/officeDocument/2006/relationships">
+  <p:cSld>
+    <p:spTree>
+      <p:nvGrpSpPr>
+        <p:cNvPr id="1" name=""/>
+        <p:cNvGrpSpPr/>
+        <p:nvPr/>
+      </p:nvGrpSpPr>
+      <p:grpSpPr>
+        <a:xfrm>
+          <a:off x="0" y="0"/>
+          <a:ext cx="0" cy="0"/>
+          <a:chOff x="0" y="0"/>
+          <a:chExt cx="0" cy="0"/>
+        </a:xfrm>
+      </p:grpSpPr>
+      <p:sp>
+        <p:nvSpPr>
+          <p:cNvPr id="2" name="Slide Image Placeholder 1"/>
+          <p:cNvSpPr>
+            <a:spLocks noGrp="1"/>
+          </p:cNvSpPr>
+          <p:nvPr>
+            <p:ph type="sldImg" idx="2"/>
+          </p:nvPr>
+        </p:nvSpPr>
+        <p:spPr/>
+      </p:sp>
+      <p:sp>
+        <p:nvSpPr>
+          <p:cNvPr id="3" name="Notes Placeholder 2"/>
+          <p:cNvSpPr>
+            <a:spLocks noGrp="1"/>
+          </p:cNvSpPr>
+          <p:nvPr>
+            <p:ph type="body" idx="3" sz="quarter"/>
+          </p:nvPr>
+        </p:nvSpPr>
+        <p:spPr/>
+        <p:txBody>
+          <a:bodyPr/>
+          <a:lstStyle/>
+          <a:p>
+            <a:r>
+              <a:t>9:15–10:15 — CHILD AND YOUNG ADULT BUILDS. Say: 'For a child, the plan is about being ready. Waiver lists can take years. Decision papers cannot be signed in a panic the week of a birthday. For a young adult, the plan is about real life: What comes in? What does rent, food, and rides really cost? And the filing itself — because at eighteen, Social Security looks at them as an adult, and the case is decided again under adult rules. We plan for that birthday starting at sixteen or seventeen, not after it.' Give one real-feeling example, without any real client's name: 'I worked with a young man turning eighteen whose family had never heard of the resource limit — two thousand dollars. One savings account in his name would have cost him his benefits. In his plan, we fixed that months before the birthday, calmly, instead of in a crisis.' Stories like this are what families remember after the Zoom ends.</a:t>
+            </a:r>
+          </a:p>
+        </p:txBody>
+      </p:sp>
+      <p:sp>
+        <p:nvSpPr>
+          <p:cNvPr id="4" name="Slide Number Placeholder 3"/>
+          <p:cNvSpPr>
+            <a:spLocks noGrp="1"/>
+          </p:cNvSpPr>
+          <p:nvPr>
+            <p:ph type="sldNum" idx="5" sz="quarter"/>
+          </p:nvPr>
+        </p:nvSpPr>
+        <p:spPr/>
+      </p:sp>
+    </p:spTree>
+  </p:cSld>
+  <p:clrMapOvr>
+    <a:masterClrMapping/>
+  </p:clrMapOvr>
+</p:notes>
 </file>
 
 <file path=ppt/slideLayouts/slideLayout1.xml><?xml version="1.0" encoding="utf-8"?>
@@ -3390,7 +4864,7 @@
                 </a:solidFill>
                 <a:latin typeface="Georgia"/>
               </a:rPr>
-              <a:t>Guidance Zooms — Help When You Get Stuck</a:t>
+              <a:t>SSA Filing Help — What You Will Get</a:t>
             </a:r>
           </a:p>
         </p:txBody>
@@ -3429,7 +4903,7 @@
                 </a:solidFill>
                 <a:latin typeface="Georgia"/>
               </a:rPr>
-              <a:t>•  A 30-minute Zoom with Jessica, on the one thing you are stuck on</a:t>
+              <a:t>•  The steps, in order, in simple words — you file it yourself, we guide you</a:t>
             </a:r>
           </a:p>
           <a:p>
@@ -3445,7 +4919,7 @@
                 </a:solidFill>
                 <a:latin typeface="Georgia"/>
               </a:rPr>
-              <a:t>•  $26 per appointment — pay, then email us to set your time</a:t>
+              <a:t>•  Jessica on Zoom with you while you file — up to 4 HOURS of guidance included, until your filing is complete</a:t>
             </a:r>
           </a:p>
           <a:p>
@@ -3461,7 +4935,7 @@
                 </a:solidFill>
                 <a:latin typeface="Georgia"/>
               </a:rPr>
-              <a:t>•  Book only when you need one — you never pay for help you did not book</a:t>
+              <a:t>•  Help with ID.me, your answers, and your Reference # — saved, so you can always get back in</a:t>
             </a:r>
           </a:p>
           <a:p>
@@ -3477,7 +4951,23 @@
                 </a:solidFill>
                 <a:latin typeface="Georgia"/>
               </a:rPr>
-              <a:t>•  Perfect after your plan, or with your results page in hand</a:t>
+              <a:t>•  $50 total, paid in full to start — need more time after 4 hours? $10 for every extra 30 minutes</a:t>
+            </a:r>
+          </a:p>
+          <a:p>
+            <a:pPr algn="l">
+              <a:spcAft>
+                <a:spcPts val="800"/>
+              </a:spcAft>
+            </a:pPr>
+            <a:r>
+              <a:rPr sz="2000" b="0" i="0">
+                <a:solidFill>
+                  <a:srgbClr val="2B2B24"/>
+                </a:solidFill>
+                <a:latin typeface="Georgia"/>
+              </a:rPr>
+              <a:t>•  Denied? Email us right away — we connect you with special needs attorneys, no upfront fee</a:t>
             </a:r>
           </a:p>
         </p:txBody>
@@ -3667,7 +5157,7 @@
                 </a:solidFill>
                 <a:latin typeface="Georgia"/>
               </a:rPr>
-              <a:t>Everything We Offer — Prices Up Front</a:t>
+              <a:t>Credit Repair — What You Will Get</a:t>
             </a:r>
           </a:p>
         </p:txBody>
@@ -3706,7 +5196,7 @@
                 </a:solidFill>
                 <a:latin typeface="Georgia"/>
               </a:rPr>
-              <a:t>•  Free consultation + your results page — FREE</a:t>
+              <a:t>•  A full analysis of your credit reports — what is hurting you, in simple words</a:t>
             </a:r>
           </a:p>
           <a:p>
@@ -3722,7 +5212,7 @@
                 </a:solidFill>
                 <a:latin typeface="Georgia"/>
               </a:rPr>
-              <a:t>•  The Plan Package (family · child 5–17 · young adult 18–26) — $399, pay 50/50</a:t>
+              <a:t>•  Your first dispute, prepared for you — you sign your own letters</a:t>
             </a:r>
           </a:p>
           <a:p>
@@ -3738,7 +5228,7 @@
                 </a:solidFill>
                 <a:latin typeface="Georgia"/>
               </a:rPr>
-              <a:t>•  SSA filing help (steps + up to 4 hours of Zoom guidance) — $50 · extra time $10 / 30 min</a:t>
+              <a:t>•  $150 total, paid in full to start (analysis + first dispute)</a:t>
             </a:r>
           </a:p>
           <a:p>
@@ -3754,7 +5244,7 @@
                 </a:solidFill>
                 <a:latin typeface="Georgia"/>
               </a:rPr>
-              <a:t>•  Credit analysis + first dispute — $150 · further help $89/month, cancel anytime</a:t>
+              <a:t>•  Need further help? Essential Repair — more disputes + monitoring — $89/month, cancel anytime</a:t>
             </a:r>
           </a:p>
           <a:p>
@@ -3770,23 +5260,7 @@
                 </a:solidFill>
                 <a:latin typeface="Georgia"/>
               </a:rPr>
-              <a:t>•  Guidance Zoom, 30 minutes — $26</a:t>
-            </a:r>
-          </a:p>
-          <a:p>
-            <a:pPr algn="l">
-              <a:spcAft>
-                <a:spcPts val="800"/>
-              </a:spcAft>
-            </a:pPr>
-            <a:r>
-              <a:rPr sz="2000" b="0" i="0">
-                <a:solidFill>
-                  <a:srgbClr val="2B2B24"/>
-                </a:solidFill>
-                <a:latin typeface="Georgia"/>
-              </a:rPr>
-              <a:t>•  Medication check — FREE · Life insurance talk — FREE</a:t>
+              <a:t>•  Plus a simple monthly budget that fits your real life</a:t>
             </a:r>
           </a:p>
         </p:txBody>
@@ -3873,45 +5347,6 @@
           </a:p>
         </p:txBody>
       </p:sp>
-      <p:sp>
-        <p:nvSpPr>
-          <p:cNvPr id="7" name="TextBox 6"/>
-          <p:cNvSpPr txBox="1"/>
-          <p:nvPr/>
-        </p:nvSpPr>
-        <p:spPr>
-          <a:xfrm>
-            <a:off x="640080" y="5394960"/>
-            <a:ext cx="10881360" cy="822960"/>
-          </a:xfrm>
-          <a:prstGeom prst="rect">
-            <a:avLst/>
-          </a:prstGeom>
-          <a:noFill/>
-        </p:spPr>
-        <p:txBody>
-          <a:bodyPr wrap="square">
-            <a:spAutoFit/>
-          </a:bodyPr>
-          <a:lstStyle/>
-          <a:p>
-            <a:pPr algn="l">
-              <a:spcAft>
-                <a:spcPts val="800"/>
-              </a:spcAft>
-            </a:pPr>
-            <a:r>
-              <a:rPr sz="1500" b="0" i="1">
-                <a:solidFill>
-                  <a:srgbClr val="BC5A28"/>
-                </a:solidFill>
-                <a:latin typeface="Georgia"/>
-              </a:rPr>
-              <a:t>No surprises. The price is the price — in writing, before you pay.</a:t>
-            </a:r>
-          </a:p>
-        </p:txBody>
-      </p:sp>
     </p:spTree>
   </p:cSld>
   <p:clrMapOvr>
@@ -3921,6 +5356,1192 @@
 </file>
 
 <file path=ppt/slides/slide12.xml><?xml version="1.0" encoding="utf-8"?>
+<p:sld xmlns:a="http://schemas.openxmlformats.org/drawingml/2006/main" xmlns:p="http://schemas.openxmlformats.org/presentationml/2006/main" xmlns:r="http://schemas.openxmlformats.org/officeDocument/2006/relationships">
+  <p:cSld>
+    <p:bg>
+      <p:bgPr>
+        <a:solidFill>
+          <a:srgbClr val="FAF6EC"/>
+        </a:solidFill>
+        <a:effectLst/>
+      </p:bgPr>
+    </p:bg>
+    <p:spTree>
+      <p:nvGrpSpPr>
+        <p:cNvPr id="1" name=""/>
+        <p:cNvGrpSpPr/>
+        <p:nvPr/>
+      </p:nvGrpSpPr>
+      <p:grpSpPr/>
+      <p:sp>
+        <p:nvSpPr>
+          <p:cNvPr id="2" name="Rectangle 1"/>
+          <p:cNvSpPr/>
+          <p:nvPr/>
+        </p:nvSpPr>
+        <p:spPr>
+          <a:xfrm>
+            <a:off x="0" y="0"/>
+            <a:ext cx="12191695" cy="1051560"/>
+          </a:xfrm>
+          <a:prstGeom prst="rect">
+            <a:avLst/>
+          </a:prstGeom>
+          <a:solidFill>
+            <a:srgbClr val="3E4A24"/>
+          </a:solidFill>
+          <a:ln>
+            <a:noFill/>
+          </a:ln>
+        </p:spPr>
+        <p:style>
+          <a:lnRef idx="1">
+            <a:schemeClr val="accent1"/>
+          </a:lnRef>
+          <a:fillRef idx="3">
+            <a:schemeClr val="accent1"/>
+          </a:fillRef>
+          <a:effectRef idx="2">
+            <a:schemeClr val="accent1"/>
+          </a:effectRef>
+          <a:fontRef idx="minor">
+            <a:schemeClr val="lt1"/>
+          </a:fontRef>
+        </p:style>
+        <p:txBody>
+          <a:bodyPr rtlCol="0" anchor="ctr"/>
+          <a:lstStyle/>
+          <a:p>
+            <a:pPr algn="ctr"/>
+          </a:p>
+        </p:txBody>
+      </p:sp>
+      <p:sp>
+        <p:nvSpPr>
+          <p:cNvPr id="3" name="TextBox 2"/>
+          <p:cNvSpPr txBox="1"/>
+          <p:nvPr/>
+        </p:nvSpPr>
+        <p:spPr>
+          <a:xfrm>
+            <a:off x="548640" y="201168"/>
+            <a:ext cx="11064240" cy="731520"/>
+          </a:xfrm>
+          <a:prstGeom prst="rect">
+            <a:avLst/>
+          </a:prstGeom>
+          <a:noFill/>
+        </p:spPr>
+        <p:txBody>
+          <a:bodyPr wrap="square">
+            <a:spAutoFit/>
+          </a:bodyPr>
+          <a:lstStyle/>
+          <a:p>
+            <a:pPr algn="l">
+              <a:spcAft>
+                <a:spcPts val="800"/>
+              </a:spcAft>
+            </a:pPr>
+            <a:r>
+              <a:rPr sz="3000" b="1" i="0">
+                <a:solidFill>
+                  <a:srgbClr val="F3EAD3"/>
+                </a:solidFill>
+                <a:latin typeface="Georgia"/>
+              </a:rPr>
+              <a:t>Medication &amp; Life Insurance — Always A Free Start</a:t>
+            </a:r>
+          </a:p>
+        </p:txBody>
+      </p:sp>
+      <p:sp>
+        <p:nvSpPr>
+          <p:cNvPr id="4" name="TextBox 3"/>
+          <p:cNvSpPr txBox="1"/>
+          <p:nvPr/>
+        </p:nvSpPr>
+        <p:spPr>
+          <a:xfrm>
+            <a:off x="640080" y="1463040"/>
+            <a:ext cx="10881360" cy="4206240"/>
+          </a:xfrm>
+          <a:prstGeom prst="rect">
+            <a:avLst/>
+          </a:prstGeom>
+          <a:noFill/>
+        </p:spPr>
+        <p:txBody>
+          <a:bodyPr wrap="square">
+            <a:spAutoFit/>
+          </a:bodyPr>
+          <a:lstStyle/>
+          <a:p>
+            <a:pPr algn="l">
+              <a:spcAft>
+                <a:spcPts val="800"/>
+              </a:spcAft>
+            </a:pPr>
+            <a:r>
+              <a:rPr sz="2000" b="0" i="0">
+                <a:solidFill>
+                  <a:srgbClr val="2B2B24"/>
+                </a:solidFill>
+                <a:latin typeface="Georgia"/>
+              </a:rPr>
+              <a:t>•  Medication check — FREE: we check GoodRx, Cost Plus Drugs, and maker help programs for every medicine you take</a:t>
+            </a:r>
+          </a:p>
+          <a:p>
+            <a:pPr algn="l">
+              <a:spcAft>
+                <a:spcPts val="800"/>
+              </a:spcAft>
+            </a:pPr>
+            <a:r>
+              <a:rPr sz="2000" b="0" i="0">
+                <a:solidFill>
+                  <a:srgbClr val="2B2B24"/>
+                </a:solidFill>
+                <a:latin typeface="Georgia"/>
+              </a:rPr>
+              <a:t>•  If your medication is on our list, the assistance forms are FREE</a:t>
+            </a:r>
+          </a:p>
+          <a:p>
+            <a:pPr algn="l">
+              <a:spcAft>
+                <a:spcPts val="800"/>
+              </a:spcAft>
+            </a:pPr>
+            <a:r>
+              <a:rPr sz="2000" b="0" i="0">
+                <a:solidFill>
+                  <a:srgbClr val="2B2B24"/>
+                </a:solidFill>
+                <a:latin typeface="Georgia"/>
+              </a:rPr>
+              <a:t>•  Life insurance talk — FREE: we look at what your family needs, with Living Benefits explained in simple words</a:t>
+            </a:r>
+          </a:p>
+          <a:p>
+            <a:pPr algn="l">
+              <a:spcAft>
+                <a:spcPts val="800"/>
+              </a:spcAft>
+            </a:pPr>
+            <a:r>
+              <a:rPr sz="2000" b="0" i="0">
+                <a:solidFill>
+                  <a:srgbClr val="2B2B24"/>
+                </a:solidFill>
+                <a:latin typeface="Georgia"/>
+              </a:rPr>
+              <a:t>•  No fee for insurance help — you pay nothing unless you approve a policy</a:t>
+            </a:r>
+          </a:p>
+        </p:txBody>
+      </p:sp>
+      <p:sp>
+        <p:nvSpPr>
+          <p:cNvPr id="5" name="Rectangle 4"/>
+          <p:cNvSpPr/>
+          <p:nvPr/>
+        </p:nvSpPr>
+        <p:spPr>
+          <a:xfrm>
+            <a:off x="0" y="6455664"/>
+            <a:ext cx="12191695" cy="402336"/>
+          </a:xfrm>
+          <a:prstGeom prst="rect">
+            <a:avLst/>
+          </a:prstGeom>
+          <a:solidFill>
+            <a:srgbClr val="3E4A24"/>
+          </a:solidFill>
+          <a:ln>
+            <a:noFill/>
+          </a:ln>
+        </p:spPr>
+        <p:style>
+          <a:lnRef idx="1">
+            <a:schemeClr val="accent1"/>
+          </a:lnRef>
+          <a:fillRef idx="3">
+            <a:schemeClr val="accent1"/>
+          </a:fillRef>
+          <a:effectRef idx="2">
+            <a:schemeClr val="accent1"/>
+          </a:effectRef>
+          <a:fontRef idx="minor">
+            <a:schemeClr val="lt1"/>
+          </a:fontRef>
+        </p:style>
+        <p:txBody>
+          <a:bodyPr rtlCol="0" anchor="ctr"/>
+          <a:lstStyle/>
+          <a:p>
+            <a:pPr algn="ctr"/>
+          </a:p>
+        </p:txBody>
+      </p:sp>
+      <p:sp>
+        <p:nvSpPr>
+          <p:cNvPr id="6" name="TextBox 5"/>
+          <p:cNvSpPr txBox="1"/>
+          <p:nvPr/>
+        </p:nvSpPr>
+        <p:spPr>
+          <a:xfrm>
+            <a:off x="548640" y="6510528"/>
+            <a:ext cx="11064240" cy="320040"/>
+          </a:xfrm>
+          <a:prstGeom prst="rect">
+            <a:avLst/>
+          </a:prstGeom>
+          <a:noFill/>
+        </p:spPr>
+        <p:txBody>
+          <a:bodyPr wrap="square">
+            <a:spAutoFit/>
+          </a:bodyPr>
+          <a:lstStyle/>
+          <a:p>
+            <a:pPr algn="l">
+              <a:spcAft>
+                <a:spcPts val="800"/>
+              </a:spcAft>
+            </a:pPr>
+            <a:r>
+              <a:rPr sz="1200" b="0" i="0">
+                <a:solidFill>
+                  <a:srgbClr val="F3EAD3"/>
+                </a:solidFill>
+                <a:latin typeface="Georgia"/>
+              </a:rPr>
+              <a:t>Southern Oak Financial &amp; Wellness  •  southernoakfw@gmail.com  •  southernoakfw.org</a:t>
+            </a:r>
+          </a:p>
+        </p:txBody>
+      </p:sp>
+    </p:spTree>
+  </p:cSld>
+  <p:clrMapOvr>
+    <a:masterClrMapping/>
+  </p:clrMapOvr>
+</p:sld>
+</file>
+
+<file path=ppt/slides/slide13.xml><?xml version="1.0" encoding="utf-8"?>
+<p:sld xmlns:a="http://schemas.openxmlformats.org/drawingml/2006/main" xmlns:p="http://schemas.openxmlformats.org/presentationml/2006/main" xmlns:r="http://schemas.openxmlformats.org/officeDocument/2006/relationships">
+  <p:cSld>
+    <p:bg>
+      <p:bgPr>
+        <a:solidFill>
+          <a:srgbClr val="FAF6EC"/>
+        </a:solidFill>
+        <a:effectLst/>
+      </p:bgPr>
+    </p:bg>
+    <p:spTree>
+      <p:nvGrpSpPr>
+        <p:cNvPr id="1" name=""/>
+        <p:cNvGrpSpPr/>
+        <p:nvPr/>
+      </p:nvGrpSpPr>
+      <p:grpSpPr/>
+      <p:sp>
+        <p:nvSpPr>
+          <p:cNvPr id="2" name="Rectangle 1"/>
+          <p:cNvSpPr/>
+          <p:nvPr/>
+        </p:nvSpPr>
+        <p:spPr>
+          <a:xfrm>
+            <a:off x="0" y="0"/>
+            <a:ext cx="12191695" cy="1051560"/>
+          </a:xfrm>
+          <a:prstGeom prst="rect">
+            <a:avLst/>
+          </a:prstGeom>
+          <a:solidFill>
+            <a:srgbClr val="3E4A24"/>
+          </a:solidFill>
+          <a:ln>
+            <a:noFill/>
+          </a:ln>
+        </p:spPr>
+        <p:style>
+          <a:lnRef idx="1">
+            <a:schemeClr val="accent1"/>
+          </a:lnRef>
+          <a:fillRef idx="3">
+            <a:schemeClr val="accent1"/>
+          </a:fillRef>
+          <a:effectRef idx="2">
+            <a:schemeClr val="accent1"/>
+          </a:effectRef>
+          <a:fontRef idx="minor">
+            <a:schemeClr val="lt1"/>
+          </a:fontRef>
+        </p:style>
+        <p:txBody>
+          <a:bodyPr rtlCol="0" anchor="ctr"/>
+          <a:lstStyle/>
+          <a:p>
+            <a:pPr algn="ctr"/>
+          </a:p>
+        </p:txBody>
+      </p:sp>
+      <p:sp>
+        <p:nvSpPr>
+          <p:cNvPr id="3" name="TextBox 2"/>
+          <p:cNvSpPr txBox="1"/>
+          <p:nvPr/>
+        </p:nvSpPr>
+        <p:spPr>
+          <a:xfrm>
+            <a:off x="548640" y="201168"/>
+            <a:ext cx="11064240" cy="731520"/>
+          </a:xfrm>
+          <a:prstGeom prst="rect">
+            <a:avLst/>
+          </a:prstGeom>
+          <a:noFill/>
+        </p:spPr>
+        <p:txBody>
+          <a:bodyPr wrap="square">
+            <a:spAutoFit/>
+          </a:bodyPr>
+          <a:lstStyle/>
+          <a:p>
+            <a:pPr algn="l">
+              <a:spcAft>
+                <a:spcPts val="800"/>
+              </a:spcAft>
+            </a:pPr>
+            <a:r>
+              <a:rPr sz="3000" b="1" i="0">
+                <a:solidFill>
+                  <a:srgbClr val="F3EAD3"/>
+                </a:solidFill>
+                <a:latin typeface="Georgia"/>
+              </a:rPr>
+              <a:t>Guidance Zooms — Help When You Get Stuck</a:t>
+            </a:r>
+          </a:p>
+        </p:txBody>
+      </p:sp>
+      <p:sp>
+        <p:nvSpPr>
+          <p:cNvPr id="4" name="TextBox 3"/>
+          <p:cNvSpPr txBox="1"/>
+          <p:nvPr/>
+        </p:nvSpPr>
+        <p:spPr>
+          <a:xfrm>
+            <a:off x="640080" y="1463040"/>
+            <a:ext cx="10881360" cy="4206240"/>
+          </a:xfrm>
+          <a:prstGeom prst="rect">
+            <a:avLst/>
+          </a:prstGeom>
+          <a:noFill/>
+        </p:spPr>
+        <p:txBody>
+          <a:bodyPr wrap="square">
+            <a:spAutoFit/>
+          </a:bodyPr>
+          <a:lstStyle/>
+          <a:p>
+            <a:pPr algn="l">
+              <a:spcAft>
+                <a:spcPts val="800"/>
+              </a:spcAft>
+            </a:pPr>
+            <a:r>
+              <a:rPr sz="2000" b="0" i="0">
+                <a:solidFill>
+                  <a:srgbClr val="2B2B24"/>
+                </a:solidFill>
+                <a:latin typeface="Georgia"/>
+              </a:rPr>
+              <a:t>•  A 30-minute Zoom with Jessica, on the one thing you are stuck on</a:t>
+            </a:r>
+          </a:p>
+          <a:p>
+            <a:pPr algn="l">
+              <a:spcAft>
+                <a:spcPts val="800"/>
+              </a:spcAft>
+            </a:pPr>
+            <a:r>
+              <a:rPr sz="2000" b="0" i="0">
+                <a:solidFill>
+                  <a:srgbClr val="2B2B24"/>
+                </a:solidFill>
+                <a:latin typeface="Georgia"/>
+              </a:rPr>
+              <a:t>•  $26 per appointment — pay, then email us to set your time</a:t>
+            </a:r>
+          </a:p>
+          <a:p>
+            <a:pPr algn="l">
+              <a:spcAft>
+                <a:spcPts val="800"/>
+              </a:spcAft>
+            </a:pPr>
+            <a:r>
+              <a:rPr sz="2000" b="0" i="0">
+                <a:solidFill>
+                  <a:srgbClr val="2B2B24"/>
+                </a:solidFill>
+                <a:latin typeface="Georgia"/>
+              </a:rPr>
+              <a:t>•  Book only when you need one — you never pay for help you did not book</a:t>
+            </a:r>
+          </a:p>
+          <a:p>
+            <a:pPr algn="l">
+              <a:spcAft>
+                <a:spcPts val="800"/>
+              </a:spcAft>
+            </a:pPr>
+            <a:r>
+              <a:rPr sz="2000" b="0" i="0">
+                <a:solidFill>
+                  <a:srgbClr val="2B2B24"/>
+                </a:solidFill>
+                <a:latin typeface="Georgia"/>
+              </a:rPr>
+              <a:t>•  Perfect after your plan, or with your results page in hand</a:t>
+            </a:r>
+          </a:p>
+        </p:txBody>
+      </p:sp>
+      <p:sp>
+        <p:nvSpPr>
+          <p:cNvPr id="5" name="Rectangle 4"/>
+          <p:cNvSpPr/>
+          <p:nvPr/>
+        </p:nvSpPr>
+        <p:spPr>
+          <a:xfrm>
+            <a:off x="0" y="6455664"/>
+            <a:ext cx="12191695" cy="402336"/>
+          </a:xfrm>
+          <a:prstGeom prst="rect">
+            <a:avLst/>
+          </a:prstGeom>
+          <a:solidFill>
+            <a:srgbClr val="3E4A24"/>
+          </a:solidFill>
+          <a:ln>
+            <a:noFill/>
+          </a:ln>
+        </p:spPr>
+        <p:style>
+          <a:lnRef idx="1">
+            <a:schemeClr val="accent1"/>
+          </a:lnRef>
+          <a:fillRef idx="3">
+            <a:schemeClr val="accent1"/>
+          </a:fillRef>
+          <a:effectRef idx="2">
+            <a:schemeClr val="accent1"/>
+          </a:effectRef>
+          <a:fontRef idx="minor">
+            <a:schemeClr val="lt1"/>
+          </a:fontRef>
+        </p:style>
+        <p:txBody>
+          <a:bodyPr rtlCol="0" anchor="ctr"/>
+          <a:lstStyle/>
+          <a:p>
+            <a:pPr algn="ctr"/>
+          </a:p>
+        </p:txBody>
+      </p:sp>
+      <p:sp>
+        <p:nvSpPr>
+          <p:cNvPr id="6" name="TextBox 5"/>
+          <p:cNvSpPr txBox="1"/>
+          <p:nvPr/>
+        </p:nvSpPr>
+        <p:spPr>
+          <a:xfrm>
+            <a:off x="548640" y="6510528"/>
+            <a:ext cx="11064240" cy="320040"/>
+          </a:xfrm>
+          <a:prstGeom prst="rect">
+            <a:avLst/>
+          </a:prstGeom>
+          <a:noFill/>
+        </p:spPr>
+        <p:txBody>
+          <a:bodyPr wrap="square">
+            <a:spAutoFit/>
+          </a:bodyPr>
+          <a:lstStyle/>
+          <a:p>
+            <a:pPr algn="l">
+              <a:spcAft>
+                <a:spcPts val="800"/>
+              </a:spcAft>
+            </a:pPr>
+            <a:r>
+              <a:rPr sz="1200" b="0" i="0">
+                <a:solidFill>
+                  <a:srgbClr val="F3EAD3"/>
+                </a:solidFill>
+                <a:latin typeface="Georgia"/>
+              </a:rPr>
+              <a:t>Southern Oak Financial &amp; Wellness  •  southernoakfw@gmail.com  •  southernoakfw.org</a:t>
+            </a:r>
+          </a:p>
+        </p:txBody>
+      </p:sp>
+    </p:spTree>
+  </p:cSld>
+  <p:clrMapOvr>
+    <a:masterClrMapping/>
+  </p:clrMapOvr>
+</p:sld>
+</file>
+
+<file path=ppt/slides/slide14.xml><?xml version="1.0" encoding="utf-8"?>
+<p:sld xmlns:a="http://schemas.openxmlformats.org/drawingml/2006/main" xmlns:p="http://schemas.openxmlformats.org/presentationml/2006/main" xmlns:r="http://schemas.openxmlformats.org/officeDocument/2006/relationships">
+  <p:cSld>
+    <p:bg>
+      <p:bgPr>
+        <a:solidFill>
+          <a:srgbClr val="FAF6EC"/>
+        </a:solidFill>
+        <a:effectLst/>
+      </p:bgPr>
+    </p:bg>
+    <p:spTree>
+      <p:nvGrpSpPr>
+        <p:cNvPr id="1" name=""/>
+        <p:cNvGrpSpPr/>
+        <p:nvPr/>
+      </p:nvGrpSpPr>
+      <p:grpSpPr/>
+      <p:sp>
+        <p:nvSpPr>
+          <p:cNvPr id="2" name="Rectangle 1"/>
+          <p:cNvSpPr/>
+          <p:nvPr/>
+        </p:nvSpPr>
+        <p:spPr>
+          <a:xfrm>
+            <a:off x="0" y="0"/>
+            <a:ext cx="12191695" cy="1051560"/>
+          </a:xfrm>
+          <a:prstGeom prst="rect">
+            <a:avLst/>
+          </a:prstGeom>
+          <a:solidFill>
+            <a:srgbClr val="3E4A24"/>
+          </a:solidFill>
+          <a:ln>
+            <a:noFill/>
+          </a:ln>
+        </p:spPr>
+        <p:style>
+          <a:lnRef idx="1">
+            <a:schemeClr val="accent1"/>
+          </a:lnRef>
+          <a:fillRef idx="3">
+            <a:schemeClr val="accent1"/>
+          </a:fillRef>
+          <a:effectRef idx="2">
+            <a:schemeClr val="accent1"/>
+          </a:effectRef>
+          <a:fontRef idx="minor">
+            <a:schemeClr val="lt1"/>
+          </a:fontRef>
+        </p:style>
+        <p:txBody>
+          <a:bodyPr rtlCol="0" anchor="ctr"/>
+          <a:lstStyle/>
+          <a:p>
+            <a:pPr algn="ctr"/>
+          </a:p>
+        </p:txBody>
+      </p:sp>
+      <p:sp>
+        <p:nvSpPr>
+          <p:cNvPr id="3" name="TextBox 2"/>
+          <p:cNvSpPr txBox="1"/>
+          <p:nvPr/>
+        </p:nvSpPr>
+        <p:spPr>
+          <a:xfrm>
+            <a:off x="548640" y="201168"/>
+            <a:ext cx="11064240" cy="731520"/>
+          </a:xfrm>
+          <a:prstGeom prst="rect">
+            <a:avLst/>
+          </a:prstGeom>
+          <a:noFill/>
+        </p:spPr>
+        <p:txBody>
+          <a:bodyPr wrap="square">
+            <a:spAutoFit/>
+          </a:bodyPr>
+          <a:lstStyle/>
+          <a:p>
+            <a:pPr algn="l">
+              <a:spcAft>
+                <a:spcPts val="800"/>
+              </a:spcAft>
+            </a:pPr>
+            <a:r>
+              <a:rPr sz="3000" b="1" i="0">
+                <a:solidFill>
+                  <a:srgbClr val="F3EAD3"/>
+                </a:solidFill>
+                <a:latin typeface="Georgia"/>
+              </a:rPr>
+              <a:t>Every Price, Up Front</a:t>
+            </a:r>
+          </a:p>
+        </p:txBody>
+      </p:sp>
+      <p:sp>
+        <p:nvSpPr>
+          <p:cNvPr id="4" name="TextBox 3"/>
+          <p:cNvSpPr txBox="1"/>
+          <p:nvPr/>
+        </p:nvSpPr>
+        <p:spPr>
+          <a:xfrm>
+            <a:off x="640080" y="1463040"/>
+            <a:ext cx="10881360" cy="4206240"/>
+          </a:xfrm>
+          <a:prstGeom prst="rect">
+            <a:avLst/>
+          </a:prstGeom>
+          <a:noFill/>
+        </p:spPr>
+        <p:txBody>
+          <a:bodyPr wrap="square">
+            <a:spAutoFit/>
+          </a:bodyPr>
+          <a:lstStyle/>
+          <a:p>
+            <a:pPr algn="l">
+              <a:spcAft>
+                <a:spcPts val="800"/>
+              </a:spcAft>
+            </a:pPr>
+            <a:r>
+              <a:rPr sz="2000" b="0" i="0">
+                <a:solidFill>
+                  <a:srgbClr val="2B2B24"/>
+                </a:solidFill>
+                <a:latin typeface="Georgia"/>
+              </a:rPr>
+              <a:t>•  Free consultation + your results page — FREE</a:t>
+            </a:r>
+          </a:p>
+          <a:p>
+            <a:pPr algn="l">
+              <a:spcAft>
+                <a:spcPts val="800"/>
+              </a:spcAft>
+            </a:pPr>
+            <a:r>
+              <a:rPr sz="2000" b="0" i="0">
+                <a:solidFill>
+                  <a:srgbClr val="2B2B24"/>
+                </a:solidFill>
+                <a:latin typeface="Georgia"/>
+              </a:rPr>
+              <a:t>•  THE PACKAGE — our only package: The Plan Package — $399, pay 50/50</a:t>
+            </a:r>
+          </a:p>
+          <a:p>
+            <a:pPr algn="l">
+              <a:spcAft>
+                <a:spcPts val="800"/>
+              </a:spcAft>
+            </a:pPr>
+            <a:r>
+              <a:rPr sz="2000" b="0" i="0">
+                <a:solidFill>
+                  <a:srgbClr val="2B2B24"/>
+                </a:solidFill>
+                <a:latin typeface="Georgia"/>
+              </a:rPr>
+              <a:t>•  Separate help (not packages): SSA filing help $50 · extra time $10 / 30 min</a:t>
+            </a:r>
+          </a:p>
+          <a:p>
+            <a:pPr algn="l">
+              <a:spcAft>
+                <a:spcPts val="800"/>
+              </a:spcAft>
+            </a:pPr>
+            <a:r>
+              <a:rPr sz="2000" b="0" i="0">
+                <a:solidFill>
+                  <a:srgbClr val="2B2B24"/>
+                </a:solidFill>
+                <a:latin typeface="Georgia"/>
+              </a:rPr>
+              <a:t>•  Separate help: Credit analysis + first dispute $150 · further help $89/month, cancel anytime</a:t>
+            </a:r>
+          </a:p>
+          <a:p>
+            <a:pPr algn="l">
+              <a:spcAft>
+                <a:spcPts val="800"/>
+              </a:spcAft>
+            </a:pPr>
+            <a:r>
+              <a:rPr sz="2000" b="0" i="0">
+                <a:solidFill>
+                  <a:srgbClr val="2B2B24"/>
+                </a:solidFill>
+                <a:latin typeface="Georgia"/>
+              </a:rPr>
+              <a:t>•  Guidance Zoom, 30 minutes — $26 · Medication check — FREE · Life insurance talk — FREE</a:t>
+            </a:r>
+          </a:p>
+        </p:txBody>
+      </p:sp>
+      <p:sp>
+        <p:nvSpPr>
+          <p:cNvPr id="5" name="Rectangle 4"/>
+          <p:cNvSpPr/>
+          <p:nvPr/>
+        </p:nvSpPr>
+        <p:spPr>
+          <a:xfrm>
+            <a:off x="0" y="6455664"/>
+            <a:ext cx="12191695" cy="402336"/>
+          </a:xfrm>
+          <a:prstGeom prst="rect">
+            <a:avLst/>
+          </a:prstGeom>
+          <a:solidFill>
+            <a:srgbClr val="3E4A24"/>
+          </a:solidFill>
+          <a:ln>
+            <a:noFill/>
+          </a:ln>
+        </p:spPr>
+        <p:style>
+          <a:lnRef idx="1">
+            <a:schemeClr val="accent1"/>
+          </a:lnRef>
+          <a:fillRef idx="3">
+            <a:schemeClr val="accent1"/>
+          </a:fillRef>
+          <a:effectRef idx="2">
+            <a:schemeClr val="accent1"/>
+          </a:effectRef>
+          <a:fontRef idx="minor">
+            <a:schemeClr val="lt1"/>
+          </a:fontRef>
+        </p:style>
+        <p:txBody>
+          <a:bodyPr rtlCol="0" anchor="ctr"/>
+          <a:lstStyle/>
+          <a:p>
+            <a:pPr algn="ctr"/>
+          </a:p>
+        </p:txBody>
+      </p:sp>
+      <p:sp>
+        <p:nvSpPr>
+          <p:cNvPr id="6" name="TextBox 5"/>
+          <p:cNvSpPr txBox="1"/>
+          <p:nvPr/>
+        </p:nvSpPr>
+        <p:spPr>
+          <a:xfrm>
+            <a:off x="548640" y="6510528"/>
+            <a:ext cx="11064240" cy="320040"/>
+          </a:xfrm>
+          <a:prstGeom prst="rect">
+            <a:avLst/>
+          </a:prstGeom>
+          <a:noFill/>
+        </p:spPr>
+        <p:txBody>
+          <a:bodyPr wrap="square">
+            <a:spAutoFit/>
+          </a:bodyPr>
+          <a:lstStyle/>
+          <a:p>
+            <a:pPr algn="l">
+              <a:spcAft>
+                <a:spcPts val="800"/>
+              </a:spcAft>
+            </a:pPr>
+            <a:r>
+              <a:rPr sz="1200" b="0" i="0">
+                <a:solidFill>
+                  <a:srgbClr val="F3EAD3"/>
+                </a:solidFill>
+                <a:latin typeface="Georgia"/>
+              </a:rPr>
+              <a:t>Southern Oak Financial &amp; Wellness  •  southernoakfw@gmail.com  •  southernoakfw.org</a:t>
+            </a:r>
+          </a:p>
+        </p:txBody>
+      </p:sp>
+      <p:sp>
+        <p:nvSpPr>
+          <p:cNvPr id="7" name="TextBox 6"/>
+          <p:cNvSpPr txBox="1"/>
+          <p:nvPr/>
+        </p:nvSpPr>
+        <p:spPr>
+          <a:xfrm>
+            <a:off x="640080" y="5394960"/>
+            <a:ext cx="10881360" cy="822960"/>
+          </a:xfrm>
+          <a:prstGeom prst="rect">
+            <a:avLst/>
+          </a:prstGeom>
+          <a:noFill/>
+        </p:spPr>
+        <p:txBody>
+          <a:bodyPr wrap="square">
+            <a:spAutoFit/>
+          </a:bodyPr>
+          <a:lstStyle/>
+          <a:p>
+            <a:pPr algn="l">
+              <a:spcAft>
+                <a:spcPts val="800"/>
+              </a:spcAft>
+            </a:pPr>
+            <a:r>
+              <a:rPr sz="1500" b="0" i="1">
+                <a:solidFill>
+                  <a:srgbClr val="BC5A28"/>
+                </a:solidFill>
+                <a:latin typeface="Georgia"/>
+              </a:rPr>
+              <a:t>No surprises. The price is the price — in writing, before you pay.</a:t>
+            </a:r>
+          </a:p>
+        </p:txBody>
+      </p:sp>
+    </p:spTree>
+  </p:cSld>
+  <p:clrMapOvr>
+    <a:masterClrMapping/>
+  </p:clrMapOvr>
+</p:sld>
+</file>
+
+<file path=ppt/slides/slide15.xml><?xml version="1.0" encoding="utf-8"?>
+<p:sld xmlns:a="http://schemas.openxmlformats.org/drawingml/2006/main" xmlns:p="http://schemas.openxmlformats.org/presentationml/2006/main" xmlns:r="http://schemas.openxmlformats.org/officeDocument/2006/relationships">
+  <p:cSld>
+    <p:bg>
+      <p:bgPr>
+        <a:solidFill>
+          <a:srgbClr val="FAF6EC"/>
+        </a:solidFill>
+        <a:effectLst/>
+      </p:bgPr>
+    </p:bg>
+    <p:spTree>
+      <p:nvGrpSpPr>
+        <p:cNvPr id="1" name=""/>
+        <p:cNvGrpSpPr/>
+        <p:nvPr/>
+      </p:nvGrpSpPr>
+      <p:grpSpPr/>
+      <p:sp>
+        <p:nvSpPr>
+          <p:cNvPr id="2" name="Rectangle 1"/>
+          <p:cNvSpPr/>
+          <p:nvPr/>
+        </p:nvSpPr>
+        <p:spPr>
+          <a:xfrm>
+            <a:off x="0" y="0"/>
+            <a:ext cx="12191695" cy="1051560"/>
+          </a:xfrm>
+          <a:prstGeom prst="rect">
+            <a:avLst/>
+          </a:prstGeom>
+          <a:solidFill>
+            <a:srgbClr val="3E4A24"/>
+          </a:solidFill>
+          <a:ln>
+            <a:noFill/>
+          </a:ln>
+        </p:spPr>
+        <p:style>
+          <a:lnRef idx="1">
+            <a:schemeClr val="accent1"/>
+          </a:lnRef>
+          <a:fillRef idx="3">
+            <a:schemeClr val="accent1"/>
+          </a:fillRef>
+          <a:effectRef idx="2">
+            <a:schemeClr val="accent1"/>
+          </a:effectRef>
+          <a:fontRef idx="minor">
+            <a:schemeClr val="lt1"/>
+          </a:fontRef>
+        </p:style>
+        <p:txBody>
+          <a:bodyPr rtlCol="0" anchor="ctr"/>
+          <a:lstStyle/>
+          <a:p>
+            <a:pPr algn="ctr"/>
+          </a:p>
+        </p:txBody>
+      </p:sp>
+      <p:sp>
+        <p:nvSpPr>
+          <p:cNvPr id="3" name="TextBox 2"/>
+          <p:cNvSpPr txBox="1"/>
+          <p:nvPr/>
+        </p:nvSpPr>
+        <p:spPr>
+          <a:xfrm>
+            <a:off x="548640" y="201168"/>
+            <a:ext cx="11064240" cy="731520"/>
+          </a:xfrm>
+          <a:prstGeom prst="rect">
+            <a:avLst/>
+          </a:prstGeom>
+          <a:noFill/>
+        </p:spPr>
+        <p:txBody>
+          <a:bodyPr wrap="square">
+            <a:spAutoFit/>
+          </a:bodyPr>
+          <a:lstStyle/>
+          <a:p>
+            <a:pPr algn="l">
+              <a:spcAft>
+                <a:spcPts val="800"/>
+              </a:spcAft>
+            </a:pPr>
+            <a:r>
+              <a:rPr sz="3000" b="1" i="0">
+                <a:solidFill>
+                  <a:srgbClr val="F3EAD3"/>
+                </a:solidFill>
+                <a:latin typeface="Georgia"/>
+              </a:rPr>
+              <a:t>Your Questions</a:t>
+            </a:r>
+          </a:p>
+        </p:txBody>
+      </p:sp>
+      <p:sp>
+        <p:nvSpPr>
+          <p:cNvPr id="4" name="TextBox 3"/>
+          <p:cNvSpPr txBox="1"/>
+          <p:nvPr/>
+        </p:nvSpPr>
+        <p:spPr>
+          <a:xfrm>
+            <a:off x="640080" y="1463040"/>
+            <a:ext cx="10881360" cy="4206240"/>
+          </a:xfrm>
+          <a:prstGeom prst="rect">
+            <a:avLst/>
+          </a:prstGeom>
+          <a:noFill/>
+        </p:spPr>
+        <p:txBody>
+          <a:bodyPr wrap="square">
+            <a:spAutoFit/>
+          </a:bodyPr>
+          <a:lstStyle/>
+          <a:p>
+            <a:pPr algn="l">
+              <a:spcAft>
+                <a:spcPts val="800"/>
+              </a:spcAft>
+            </a:pPr>
+            <a:r>
+              <a:rPr sz="2000" b="0" i="0">
+                <a:solidFill>
+                  <a:srgbClr val="2B2B24"/>
+                </a:solidFill>
+                <a:latin typeface="Georgia"/>
+              </a:rPr>
+              <a:t>•  What worries you most right now?</a:t>
+            </a:r>
+          </a:p>
+          <a:p>
+            <a:pPr algn="l">
+              <a:spcAft>
+                <a:spcPts val="800"/>
+              </a:spcAft>
+            </a:pPr>
+            <a:r>
+              <a:rPr sz="2000" b="0" i="0">
+                <a:solidFill>
+                  <a:srgbClr val="2B2B24"/>
+                </a:solidFill>
+                <a:latin typeface="Georgia"/>
+              </a:rPr>
+              <a:t>•  What would change for your family if that one thing was handled?</a:t>
+            </a:r>
+          </a:p>
+          <a:p>
+            <a:pPr algn="l">
+              <a:spcAft>
+                <a:spcPts val="800"/>
+              </a:spcAft>
+            </a:pPr>
+            <a:r>
+              <a:rPr sz="2000" b="0" i="0">
+                <a:solidFill>
+                  <a:srgbClr val="2B2B24"/>
+                </a:solidFill>
+                <a:latin typeface="Georgia"/>
+              </a:rPr>
+              <a:t>•  Ask me anything about how we work — I will answer it straight</a:t>
+            </a:r>
+          </a:p>
+        </p:txBody>
+      </p:sp>
+      <p:sp>
+        <p:nvSpPr>
+          <p:cNvPr id="5" name="Rectangle 4"/>
+          <p:cNvSpPr/>
+          <p:nvPr/>
+        </p:nvSpPr>
+        <p:spPr>
+          <a:xfrm>
+            <a:off x="0" y="6455664"/>
+            <a:ext cx="12191695" cy="402336"/>
+          </a:xfrm>
+          <a:prstGeom prst="rect">
+            <a:avLst/>
+          </a:prstGeom>
+          <a:solidFill>
+            <a:srgbClr val="3E4A24"/>
+          </a:solidFill>
+          <a:ln>
+            <a:noFill/>
+          </a:ln>
+        </p:spPr>
+        <p:style>
+          <a:lnRef idx="1">
+            <a:schemeClr val="accent1"/>
+          </a:lnRef>
+          <a:fillRef idx="3">
+            <a:schemeClr val="accent1"/>
+          </a:fillRef>
+          <a:effectRef idx="2">
+            <a:schemeClr val="accent1"/>
+          </a:effectRef>
+          <a:fontRef idx="minor">
+            <a:schemeClr val="lt1"/>
+          </a:fontRef>
+        </p:style>
+        <p:txBody>
+          <a:bodyPr rtlCol="0" anchor="ctr"/>
+          <a:lstStyle/>
+          <a:p>
+            <a:pPr algn="ctr"/>
+          </a:p>
+        </p:txBody>
+      </p:sp>
+      <p:sp>
+        <p:nvSpPr>
+          <p:cNvPr id="6" name="TextBox 5"/>
+          <p:cNvSpPr txBox="1"/>
+          <p:nvPr/>
+        </p:nvSpPr>
+        <p:spPr>
+          <a:xfrm>
+            <a:off x="548640" y="6510528"/>
+            <a:ext cx="11064240" cy="320040"/>
+          </a:xfrm>
+          <a:prstGeom prst="rect">
+            <a:avLst/>
+          </a:prstGeom>
+          <a:noFill/>
+        </p:spPr>
+        <p:txBody>
+          <a:bodyPr wrap="square">
+            <a:spAutoFit/>
+          </a:bodyPr>
+          <a:lstStyle/>
+          <a:p>
+            <a:pPr algn="l">
+              <a:spcAft>
+                <a:spcPts val="800"/>
+              </a:spcAft>
+            </a:pPr>
+            <a:r>
+              <a:rPr sz="1200" b="0" i="0">
+                <a:solidFill>
+                  <a:srgbClr val="F3EAD3"/>
+                </a:solidFill>
+                <a:latin typeface="Georgia"/>
+              </a:rPr>
+              <a:t>Southern Oak Financial &amp; Wellness  •  southernoakfw@gmail.com  •  southernoakfw.org</a:t>
+            </a:r>
+          </a:p>
+        </p:txBody>
+      </p:sp>
+      <p:sp>
+        <p:nvSpPr>
+          <p:cNvPr id="7" name="TextBox 6"/>
+          <p:cNvSpPr txBox="1"/>
+          <p:nvPr/>
+        </p:nvSpPr>
+        <p:spPr>
+          <a:xfrm>
+            <a:off x="640080" y="5394960"/>
+            <a:ext cx="10881360" cy="822960"/>
+          </a:xfrm>
+          <a:prstGeom prst="rect">
+            <a:avLst/>
+          </a:prstGeom>
+          <a:noFill/>
+        </p:spPr>
+        <p:txBody>
+          <a:bodyPr wrap="square">
+            <a:spAutoFit/>
+          </a:bodyPr>
+          <a:lstStyle/>
+          <a:p>
+            <a:pPr algn="l">
+              <a:spcAft>
+                <a:spcPts val="800"/>
+              </a:spcAft>
+            </a:pPr>
+            <a:r>
+              <a:rPr sz="1500" b="0" i="1">
+                <a:solidFill>
+                  <a:srgbClr val="BC5A28"/>
+                </a:solidFill>
+                <a:latin typeface="Georgia"/>
+              </a:rPr>
+              <a:t>There is no wrong question here.</a:t>
+            </a:r>
+          </a:p>
+        </p:txBody>
+      </p:sp>
+    </p:spTree>
+  </p:cSld>
+  <p:clrMapOvr>
+    <a:masterClrMapping/>
+  </p:clrMapOvr>
+</p:sld>
+</file>
+
+<file path=ppt/slides/slide16.xml><?xml version="1.0" encoding="utf-8"?>
 <p:sld xmlns:a="http://schemas.openxmlformats.org/drawingml/2006/main" xmlns:p="http://schemas.openxmlformats.org/presentationml/2006/main" xmlns:r="http://schemas.openxmlformats.org/officeDocument/2006/relationships">
   <p:cSld>
     <p:bg>
@@ -3946,7 +6567,7 @@
         </p:nvSpPr>
         <p:spPr>
           <a:xfrm>
-            <a:off x="1097280" y="1097280"/>
+            <a:off x="1097280" y="914400"/>
             <a:ext cx="9966960" cy="1097280"/>
           </a:xfrm>
           <a:prstGeom prst="rect">
@@ -3985,7 +6606,7 @@
         </p:nvSpPr>
         <p:spPr>
           <a:xfrm>
-            <a:off x="1554480" y="2377440"/>
+            <a:off x="1554480" y="2011680"/>
             <a:ext cx="9052560" cy="2011680"/>
           </a:xfrm>
           <a:prstGeom prst="rect">
@@ -4072,7 +6693,7 @@
         </p:nvSpPr>
         <p:spPr>
           <a:xfrm>
-            <a:off x="1097280" y="4846320"/>
+            <a:off x="1097280" y="4480560"/>
             <a:ext cx="9966960" cy="731520"/>
           </a:xfrm>
           <a:prstGeom prst="rect">
@@ -4111,7 +6732,7 @@
         </p:nvSpPr>
         <p:spPr>
           <a:xfrm>
-            <a:off x="1097280" y="5852160"/>
+            <a:off x="1097280" y="5669280"/>
             <a:ext cx="9966960" cy="822960"/>
           </a:xfrm>
           <a:prstGeom prst="rect">
@@ -5456,7 +8077,7 @@
                 </a:solidFill>
                 <a:latin typeface="Georgia"/>
               </a:rPr>
-              <a:t>The Plan Package — What You Will Get</a:t>
+              <a:t>Your Results Page — Yours To Keep, Free</a:t>
             </a:r>
           </a:p>
         </p:txBody>
@@ -5495,7 +8116,7 @@
                 </a:solidFill>
                 <a:latin typeface="Georgia"/>
               </a:rPr>
-              <a:t>•  Your full written plan — built from your intake, for your family, your child (5–17), or your young adult (18–26)</a:t>
+              <a:t>•  Where you are — in each of the six areas, in simple words</a:t>
             </a:r>
           </a:p>
           <a:p>
@@ -5511,7 +8132,7 @@
                 </a:solidFill>
                 <a:latin typeface="Georgia"/>
               </a:rPr>
-              <a:t>•  What to work on FIRST, marked clear — your steps in order, with every deadline written down</a:t>
+              <a:t>•  What you need — the gaps we found</a:t>
             </a:r>
           </a:p>
           <a:p>
@@ -5527,7 +8148,7 @@
                 </a:solidFill>
                 <a:latin typeface="Georgia"/>
               </a:rPr>
-              <a:t>•  A delivery Zoom with Jessica to walk through your plan together</a:t>
+              <a:t>•  Your first steps — in order: 1, 2, 3</a:t>
             </a:r>
           </a:p>
           <a:p>
@@ -5543,7 +8164,7 @@
                 </a:solidFill>
                 <a:latin typeface="Georgia"/>
               </a:rPr>
-              <a:t>•  $399 one time — pay 50/50: $199.50 when you sign, $199.50 before we provide your plan</a:t>
+              <a:t>•  Our recommendation — and exactly what it costs, in writing</a:t>
             </a:r>
           </a:p>
         </p:txBody>
@@ -5664,7 +8285,7 @@
                 </a:solidFill>
                 <a:latin typeface="Georgia"/>
               </a:rPr>
-              <a:t>Planning firms charge about $2,926 on average to build a plan. Ours is built for families like yours.</a:t>
+              <a:t>No surprises. No pressure. The results page is yours either way.</a:t>
             </a:r>
           </a:p>
         </p:txBody>
@@ -5772,7 +8393,7 @@
                 </a:solidFill>
                 <a:latin typeface="Georgia"/>
               </a:rPr>
-              <a:t>SSA Filing Help — What You Will Get</a:t>
+              <a:t>Our Only Package — The Plan Package</a:t>
             </a:r>
           </a:p>
         </p:txBody>
@@ -5811,7 +8432,7 @@
                 </a:solidFill>
                 <a:latin typeface="Georgia"/>
               </a:rPr>
-              <a:t>•  The steps, in order, in simple words — you file it yourself, we guide you</a:t>
+              <a:t>•  One package. One price. We do not sell levels or tiers</a:t>
             </a:r>
           </a:p>
           <a:p>
@@ -5827,7 +8448,7 @@
                 </a:solidFill>
                 <a:latin typeface="Georgia"/>
               </a:rPr>
-              <a:t>•  Jessica on Zoom with you while you file — up to 4 HOURS of guidance included, until your filing is complete</a:t>
+              <a:t>•  We build your full written plan from your intake — for a family, a child (5–17), or a young adult (18–26)</a:t>
             </a:r>
           </a:p>
           <a:p>
@@ -5843,7 +8464,7 @@
                 </a:solidFill>
                 <a:latin typeface="Georgia"/>
               </a:rPr>
-              <a:t>•  Help with ID.me, your answers, and your Reference # — saved, so you can always get back in</a:t>
+              <a:t>•  What to work on FIRST, marked clear — your steps in order, with every deadline written down</a:t>
             </a:r>
           </a:p>
           <a:p>
@@ -5859,7 +8480,7 @@
                 </a:solidFill>
                 <a:latin typeface="Georgia"/>
               </a:rPr>
-              <a:t>•  $50 total, paid in full to start — need more time after 4 hours? $10 for every extra 30 minutes</a:t>
+              <a:t>•  A delivery Zoom with Jessica to walk through your plan together</a:t>
             </a:r>
           </a:p>
           <a:p>
@@ -5875,7 +8496,7 @@
                 </a:solidFill>
                 <a:latin typeface="Georgia"/>
               </a:rPr>
-              <a:t>•  Denied? Email us right away — we connect you with special needs attorneys, no upfront fee</a:t>
+              <a:t>•  $399 one time — pay 50/50: $199.50 when you sign, $199.50 before we provide your plan</a:t>
             </a:r>
           </a:p>
         </p:txBody>
@@ -5958,6 +8579,45 @@
                 <a:latin typeface="Georgia"/>
               </a:rPr>
               <a:t>Southern Oak Financial &amp; Wellness  •  southernoakfw@gmail.com  •  southernoakfw.org</a:t>
+            </a:r>
+          </a:p>
+        </p:txBody>
+      </p:sp>
+      <p:sp>
+        <p:nvSpPr>
+          <p:cNvPr id="7" name="TextBox 6"/>
+          <p:cNvSpPr txBox="1"/>
+          <p:nvPr/>
+        </p:nvSpPr>
+        <p:spPr>
+          <a:xfrm>
+            <a:off x="640080" y="5394960"/>
+            <a:ext cx="10881360" cy="822960"/>
+          </a:xfrm>
+          <a:prstGeom prst="rect">
+            <a:avLst/>
+          </a:prstGeom>
+          <a:noFill/>
+        </p:spPr>
+        <p:txBody>
+          <a:bodyPr wrap="square">
+            <a:spAutoFit/>
+          </a:bodyPr>
+          <a:lstStyle/>
+          <a:p>
+            <a:pPr algn="l">
+              <a:spcAft>
+                <a:spcPts val="800"/>
+              </a:spcAft>
+            </a:pPr>
+            <a:r>
+              <a:rPr sz="1500" b="0" i="1">
+                <a:solidFill>
+                  <a:srgbClr val="BC5A28"/>
+                </a:solidFill>
+                <a:latin typeface="Georgia"/>
+              </a:rPr>
+              <a:t>Planning firms charge about $2,926 on average to build a plan. Ours is built for families like yours.</a:t>
             </a:r>
           </a:p>
         </p:txBody>
@@ -6065,7 +8725,7 @@
                 </a:solidFill>
                 <a:latin typeface="Georgia"/>
               </a:rPr>
-              <a:t>Credit Repair — What You Will Get</a:t>
+              <a:t>If Your Plan Is For Your Family</a:t>
             </a:r>
           </a:p>
         </p:txBody>
@@ -6104,7 +8764,7 @@
                 </a:solidFill>
                 <a:latin typeface="Georgia"/>
               </a:rPr>
-              <a:t>•  A full analysis of your credit reports — what is hurting you, in simple words</a:t>
+              <a:t>•  All six areas reviewed together — benefits, medication, protection, budget &amp; credit, what is in place, the road ahead</a:t>
             </a:r>
           </a:p>
           <a:p>
@@ -6120,7 +8780,7 @@
                 </a:solidFill>
                 <a:latin typeface="Georgia"/>
               </a:rPr>
-              <a:t>•  Your first dispute, prepared for you — you sign your own letters</a:t>
+              <a:t>•  The one thing to work on FIRST — most families try to fix everything at once; your plan gives you an order</a:t>
             </a:r>
           </a:p>
           <a:p>
@@ -6136,7 +8796,7 @@
                 </a:solidFill>
                 <a:latin typeface="Georgia"/>
               </a:rPr>
-              <a:t>•  $150 total, paid in full to start (analysis + first dispute)</a:t>
+              <a:t>•  Every deadline on paper — appeals, renewals, waiver lists, the eighteenth birthday</a:t>
             </a:r>
           </a:p>
           <a:p>
@@ -6152,23 +8812,7 @@
                 </a:solidFill>
                 <a:latin typeface="Georgia"/>
               </a:rPr>
-              <a:t>•  Need further help? Essential Repair — more disputes + monitoring — $89/month, cancel anytime</a:t>
-            </a:r>
-          </a:p>
-          <a:p>
-            <a:pPr algn="l">
-              <a:spcAft>
-                <a:spcPts val="800"/>
-              </a:spcAft>
-            </a:pPr>
-            <a:r>
-              <a:rPr sz="2000" b="0" i="0">
-                <a:solidFill>
-                  <a:srgbClr val="2B2B24"/>
-                </a:solidFill>
-                <a:latin typeface="Georgia"/>
-              </a:rPr>
-              <a:t>•  Plus a simple monthly budget that fits your real life</a:t>
+              <a:t>•  Simple words, in order, in one folder your whole family can follow</a:t>
             </a:r>
           </a:p>
         </p:txBody>
@@ -6358,7 +9002,7 @@
                 </a:solidFill>
                 <a:latin typeface="Georgia"/>
               </a:rPr>
-              <a:t>Medication &amp; Life Insurance — Always a Free Start</a:t>
+              <a:t>If Your Plan Is For Your Child Or Young Adult</a:t>
             </a:r>
           </a:p>
         </p:txBody>
@@ -6397,7 +9041,7 @@
                 </a:solidFill>
                 <a:latin typeface="Georgia"/>
               </a:rPr>
-              <a:t>•  Medication check — FREE: we check GoodRx, Cost Plus Drugs, and maker help programs for every medicine you take</a:t>
+              <a:t>•  Child, ages 5–17 — what to expect at each stage, prepare the file now, get ready for 18</a:t>
             </a:r>
           </a:p>
           <a:p>
@@ -6413,7 +9057,7 @@
                 </a:solidFill>
                 <a:latin typeface="Georgia"/>
               </a:rPr>
-              <a:t>•  If your medication is on our list, the assistance forms are FREE</a:t>
+              <a:t>•  The papers that take time: decision papers, the $2,000 rule, ABLE accounts, waiver waiting lists</a:t>
             </a:r>
           </a:p>
           <a:p>
@@ -6429,7 +9073,7 @@
                 </a:solidFill>
                 <a:latin typeface="Georgia"/>
               </a:rPr>
-              <a:t>•  Life insurance talk — FREE: we look at what your family needs, with Living Benefits explained in simple words</a:t>
+              <a:t>•  Young adult, ages 18–26 — a budget on their real income, a living plan with real costs and rides</a:t>
             </a:r>
           </a:p>
           <a:p>
@@ -6445,7 +9089,7 @@
                 </a:solidFill>
                 <a:latin typeface="Georgia"/>
               </a:rPr>
-              <a:t>•  No fee for insurance help — you pay nothing unless you approve a policy</a:t>
+              <a:t>•  And the SSA filing plan under adult rules — because at 18, Social Security decides again</a:t>
             </a:r>
           </a:p>
         </p:txBody>
@@ -6858,4 +9502,324 @@
   </a:objectDefaults>
   <a:extraClrSchemeLst/>
 </a:theme>
+</file>
+
+<file path=ppt/theme/theme2.xml><?xml version="1.0" encoding="utf-8"?>
+<a:theme xmlns:a="http://schemas.openxmlformats.org/drawingml/2006/main" name="Office Theme">
+  <a:themeElements>
+    <a:clrScheme name="Office">
+      <a:dk1>
+        <a:sysClr val="windowText" lastClr="000000"/>
+      </a:dk1>
+      <a:lt1>
+        <a:sysClr val="window" lastClr="FFFFFF"/>
+      </a:lt1>
+      <a:dk2>
+        <a:srgbClr val="1F497D"/>
+      </a:dk2>
+      <a:lt2>
+        <a:srgbClr val="EEECE1"/>
+      </a:lt2>
+      <a:accent1>
+        <a:srgbClr val="4F81BD"/>
+      </a:accent1>
+      <a:accent2>
+        <a:srgbClr val="C0504D"/>
+      </a:accent2>
+      <a:accent3>
+        <a:srgbClr val="9BBB59"/>
+      </a:accent3>
+      <a:accent4>
+        <a:srgbClr val="8064A2"/>
+      </a:accent4>
+      <a:accent5>
+        <a:srgbClr val="4BACC6"/>
+      </a:accent5>
+      <a:accent6>
+        <a:srgbClr val="F79646"/>
+      </a:accent6>
+      <a:hlink>
+        <a:srgbClr val="0000FF"/>
+      </a:hlink>
+      <a:folHlink>
+        <a:srgbClr val="800080"/>
+      </a:folHlink>
+    </a:clrScheme>
+    <a:fontScheme name="Office">
+      <a:majorFont>
+        <a:latin typeface="Calibri"/>
+        <a:ea typeface=""/>
+        <a:cs typeface=""/>
+        <a:font script="Jpan" typeface="ＭＳ Ｐゴシック"/>
+        <a:font script="Hang" typeface="맑은 고딕"/>
+        <a:font script="Hans" typeface="宋体"/>
+        <a:font script="Hant" typeface="新細明體"/>
+        <a:font script="Arab" typeface="Times New Roman"/>
+        <a:font script="Hebr" typeface="Times New Roman"/>
+        <a:font script="Thai" typeface="Angsana New"/>
+        <a:font script="Ethi" typeface="Nyala"/>
+        <a:font script="Beng" typeface="Vrinda"/>
+        <a:font script="Gujr" typeface="Shruti"/>
+        <a:font script="Khmr" typeface="MoolBoran"/>
+        <a:font script="Knda" typeface="Tunga"/>
+        <a:font script="Guru" typeface="Raavi"/>
+        <a:font script="Cans" typeface="Euphemia"/>
+        <a:font script="Cher" typeface="Plantagenet Cherokee"/>
+        <a:font script="Yiii" typeface="Microsoft Yi Baiti"/>
+        <a:font script="Tibt" typeface="Microsoft Himalaya"/>
+        <a:font script="Thaa" typeface="MV Boli"/>
+        <a:font script="Deva" typeface="Mangal"/>
+        <a:font script="Telu" typeface="Gautami"/>
+        <a:font script="Taml" typeface="Latha"/>
+        <a:font script="Syrc" typeface="Estrangelo Edessa"/>
+        <a:font script="Orya" typeface="Kalinga"/>
+        <a:font script="Mlym" typeface="Kartika"/>
+        <a:font script="Laoo" typeface="DokChampa"/>
+        <a:font script="Sinh" typeface="Iskoola Pota"/>
+        <a:font script="Mong" typeface="Mongolian Baiti"/>
+        <a:font script="Viet" typeface="Times New Roman"/>
+        <a:font script="Uigh" typeface="Microsoft Uighur"/>
+        <a:font script="Geor" typeface="Sylfaen"/>
+      </a:majorFont>
+      <a:minorFont>
+        <a:latin typeface="Calibri"/>
+        <a:ea typeface=""/>
+        <a:cs typeface=""/>
+        <a:font script="Jpan" typeface="ＭＳ Ｐゴシック"/>
+        <a:font script="Hang" typeface="맑은 고딕"/>
+        <a:font script="Hans" typeface="宋体"/>
+        <a:font script="Hant" typeface="新細明體"/>
+        <a:font script="Arab" typeface="Arial"/>
+        <a:font script="Hebr" typeface="Arial"/>
+        <a:font script="Thai" typeface="Cordia New"/>
+        <a:font script="Ethi" typeface="Nyala"/>
+        <a:font script="Beng" typeface="Vrinda"/>
+        <a:font script="Gujr" typeface="Shruti"/>
+        <a:font script="Khmr" typeface="DaunPenh"/>
+        <a:font script="Knda" typeface="Tunga"/>
+        <a:font script="Guru" typeface="Raavi"/>
+        <a:font script="Cans" typeface="Euphemia"/>
+        <a:font script="Cher" typeface="Plantagenet Cherokee"/>
+        <a:font script="Yiii" typeface="Microsoft Yi Baiti"/>
+        <a:font script="Tibt" typeface="Microsoft Himalaya"/>
+        <a:font script="Thaa" typeface="MV Boli"/>
+        <a:font script="Deva" typeface="Mangal"/>
+        <a:font script="Telu" typeface="Gautami"/>
+        <a:font script="Taml" typeface="Latha"/>
+        <a:font script="Syrc" typeface="Estrangelo Edessa"/>
+        <a:font script="Orya" typeface="Kalinga"/>
+        <a:font script="Mlym" typeface="Kartika"/>
+        <a:font script="Laoo" typeface="DokChampa"/>
+        <a:font script="Sinh" typeface="Iskoola Pota"/>
+        <a:font script="Mong" typeface="Mongolian Baiti"/>
+        <a:font script="Viet" typeface="Arial"/>
+        <a:font script="Uigh" typeface="Microsoft Uighur"/>
+        <a:font script="Geor" typeface="Sylfaen"/>
+      </a:minorFont>
+    </a:fontScheme>
+    <a:fmtScheme name="Office">
+      <a:fillStyleLst>
+        <a:solidFill>
+          <a:schemeClr val="phClr"/>
+        </a:solidFill>
+        <a:gradFill rotWithShape="1">
+          <a:gsLst>
+            <a:gs pos="0">
+              <a:schemeClr val="phClr">
+                <a:tint val="50000"/>
+                <a:satMod val="300000"/>
+              </a:schemeClr>
+            </a:gs>
+            <a:gs pos="35000">
+              <a:schemeClr val="phClr">
+                <a:tint val="37000"/>
+                <a:satMod val="300000"/>
+              </a:schemeClr>
+            </a:gs>
+            <a:gs pos="100000">
+              <a:schemeClr val="phClr">
+                <a:tint val="15000"/>
+                <a:satMod val="350000"/>
+              </a:schemeClr>
+            </a:gs>
+          </a:gsLst>
+          <a:lin ang="16200000" scaled="1"/>
+        </a:gradFill>
+        <a:gradFill rotWithShape="1">
+          <a:gsLst>
+            <a:gs pos="0">
+              <a:schemeClr val="phClr">
+                <a:tint val="100000"/>
+                <a:shade val="100000"/>
+                <a:satMod val="130000"/>
+              </a:schemeClr>
+            </a:gs>
+            <a:gs pos="100000">
+              <a:schemeClr val="phClr">
+                <a:tint val="50000"/>
+                <a:shade val="100000"/>
+                <a:satMod val="350000"/>
+              </a:schemeClr>
+            </a:gs>
+          </a:gsLst>
+          <a:lin ang="16200000" scaled="0"/>
+        </a:gradFill>
+      </a:fillStyleLst>
+      <a:lnStyleLst>
+        <a:ln w="9525" cap="flat" cmpd="sng" algn="ctr">
+          <a:solidFill>
+            <a:schemeClr val="phClr">
+              <a:shade val="95000"/>
+              <a:satMod val="105000"/>
+            </a:schemeClr>
+          </a:solidFill>
+          <a:prstDash val="solid"/>
+        </a:ln>
+        <a:ln w="25400" cap="flat" cmpd="sng" algn="ctr">
+          <a:solidFill>
+            <a:schemeClr val="phClr"/>
+          </a:solidFill>
+          <a:prstDash val="solid"/>
+        </a:ln>
+        <a:ln w="38100" cap="flat" cmpd="sng" algn="ctr">
+          <a:solidFill>
+            <a:schemeClr val="phClr"/>
+          </a:solidFill>
+          <a:prstDash val="solid"/>
+        </a:ln>
+      </a:lnStyleLst>
+      <a:effectStyleLst>
+        <a:effectStyle>
+          <a:effectLst>
+            <a:outerShdw blurRad="40000" dist="20000" dir="5400000" rotWithShape="0">
+              <a:srgbClr val="000000">
+                <a:alpha val="38000"/>
+              </a:srgbClr>
+            </a:outerShdw>
+          </a:effectLst>
+        </a:effectStyle>
+        <a:effectStyle>
+          <a:effectLst>
+            <a:outerShdw blurRad="40000" dist="23000" dir="5400000" rotWithShape="0">
+              <a:srgbClr val="000000">
+                <a:alpha val="35000"/>
+              </a:srgbClr>
+            </a:outerShdw>
+          </a:effectLst>
+        </a:effectStyle>
+        <a:effectStyle>
+          <a:effectLst>
+            <a:outerShdw blurRad="40000" dist="23000" dir="5400000" rotWithShape="0">
+              <a:srgbClr val="000000">
+                <a:alpha val="35000"/>
+              </a:srgbClr>
+            </a:outerShdw>
+          </a:effectLst>
+          <a:scene3d>
+            <a:camera prst="orthographicFront">
+              <a:rot lat="0" lon="0" rev="0"/>
+            </a:camera>
+            <a:lightRig rig="threePt" dir="t">
+              <a:rot lat="0" lon="0" rev="1200000"/>
+            </a:lightRig>
+          </a:scene3d>
+          <a:sp3d>
+            <a:bevelT w="63500" h="25400"/>
+          </a:sp3d>
+        </a:effectStyle>
+      </a:effectStyleLst>
+      <a:bgFillStyleLst>
+        <a:solidFill>
+          <a:schemeClr val="phClr"/>
+        </a:solidFill>
+        <a:gradFill rotWithShape="1">
+          <a:gsLst>
+            <a:gs pos="0">
+              <a:schemeClr val="phClr">
+                <a:tint val="40000"/>
+                <a:satMod val="350000"/>
+              </a:schemeClr>
+            </a:gs>
+            <a:gs pos="40000">
+              <a:schemeClr val="phClr">
+                <a:tint val="45000"/>
+                <a:shade val="99000"/>
+                <a:satMod val="350000"/>
+              </a:schemeClr>
+            </a:gs>
+            <a:gs pos="100000">
+              <a:schemeClr val="phClr">
+                <a:shade val="20000"/>
+                <a:satMod val="255000"/>
+              </a:schemeClr>
+            </a:gs>
+          </a:gsLst>
+          <a:path path="circle">
+            <a:fillToRect l="50000" t="-80000" r="50000" b="180000"/>
+          </a:path>
+        </a:gradFill>
+        <a:gradFill rotWithShape="1">
+          <a:gsLst>
+            <a:gs pos="0">
+              <a:schemeClr val="phClr">
+                <a:tint val="80000"/>
+                <a:satMod val="300000"/>
+              </a:schemeClr>
+            </a:gs>
+            <a:gs pos="100000">
+              <a:schemeClr val="phClr">
+                <a:shade val="30000"/>
+                <a:satMod val="200000"/>
+              </a:schemeClr>
+            </a:gs>
+          </a:gsLst>
+          <a:path path="circle">
+            <a:fillToRect l="50000" t="50000" r="50000" b="50000"/>
+          </a:path>
+        </a:gradFill>
+      </a:bgFillStyleLst>
+    </a:fmtScheme>
+  </a:themeElements>
+  <a:objectDefaults>
+    <a:spDef>
+      <a:spPr/>
+      <a:bodyPr/>
+      <a:lstStyle/>
+      <a:style>
+        <a:lnRef idx="1">
+          <a:schemeClr val="accent1"/>
+        </a:lnRef>
+        <a:fillRef idx="3">
+          <a:schemeClr val="accent1"/>
+        </a:fillRef>
+        <a:effectRef idx="2">
+          <a:schemeClr val="accent1"/>
+        </a:effectRef>
+        <a:fontRef idx="minor">
+          <a:schemeClr val="lt1"/>
+        </a:fontRef>
+      </a:style>
+    </a:spDef>
+    <a:lnDef>
+      <a:spPr/>
+      <a:bodyPr/>
+      <a:lstStyle/>
+      <a:style>
+        <a:lnRef idx="2">
+          <a:schemeClr val="accent1"/>
+        </a:lnRef>
+        <a:fillRef idx="0">
+          <a:schemeClr val="accent1"/>
+        </a:fillRef>
+        <a:effectRef idx="1">
+          <a:schemeClr val="accent1"/>
+        </a:effectRef>
+        <a:fontRef idx="minor">
+          <a:schemeClr val="tx1"/>
+        </a:fontRef>
+      </a:style>
+    </a:lnDef>
+  </a:objectDefaults>
+  <a:extraClrSchemeLst/>
+</a:theme>
 </file>
</xml_diff>

<commit_message>
Remove $26 guidance everywhere; SSA help includes 4 hours; simpler Book page
</commit_message>
<xml_diff>
--- a/assets/Southern-Oak-What-We-Do.pptx
+++ b/assets/Southern-Oak-What-We-Do.pptx
@@ -587,7 +587,7 @@
           <a:lstStyle/>
           <a:p>
             <a:r>
-              <a:t>10:15–11:15 — SSA FILING HELP. Be clear this is separate help, not a package. Say: 'If all you need is help filing, that is fifty dollars, paid in full. I give you the steps, YOU file it yourself — it is your case, your signature — and I am on Zoom guiding you, up to four hours, until the filing is done. If we need more time, it is ten dollars for every extra thirty minutes, and only for the time we use. And if Social Security says no — email me right away. Deadlines matter, and I will connect you with special needs attorneys who charge nothing up front.' Also prepare them for what comes after the filing: 'Social Security will mail you letters — open every one. If they schedule an exam, Social Security pays for it, not you. And write your Reference Number down and send it to me — that number is how we get back into your case.' Families panic at the letters; warning them here turns panic into a plan.</a:t>
+              <a:t>10:15–11:15 — SSA FILING HELP. Be clear this is separate help, not a package. Say: 'If all you need is help filing, that is fifty dollars, paid in full. I give you the steps, YOU file it yourself — it is your case, your signature — and I am on Zoom guiding you, up to four hours, until the filing is done. If we need more time, it is ten dollars for every extra thirty minutes, and only for the time we use. And if Social Security says no — email me right away. Deadlines matter, and I will connect you with special needs attorneys who charge nothing up front.'</a:t>
             </a:r>
           </a:p>
         </p:txBody>
@@ -797,7 +797,7 @@
           <a:lstStyle/>
           <a:p>
             <a:r>
-              <a:t>12:45–13:15 — GUIDANCE. Say: 'And whenever you get stuck — with your plan, with a letter, with a form — you can book one guidance Zoom at a time. Twenty-six dollars for thirty minutes. You book it only when you need it. You never pay for help sitting unused.'</a:t>
+              <a:t>12:45–13:15 — HELP IS INCLUDED. Say: 'When you choose filing help, my time comes with it — up to four hours of Zoom guidance while you file, because I guide and you file. If we ever need more time, it is ten dollars for every thirty minutes, and only for the time we actually use. You are never left alone with the forms.'</a:t>
             </a:r>
           </a:p>
         </p:txBody>
@@ -867,7 +867,7 @@
           <a:lstStyle/>
           <a:p>
             <a:r>
-              <a:t>13:15–14:00 — PRICES. Say it plainly, all of it, and pause: 'Here is everything, on one slide. The consultation and your results are free. We have ONE package — the Plan Package, three ninety-nine, half and half. Everything else is separate help, only if you need it: filing help fifty, credit analysis one fifty, guidance twenty-six. Nothing is hidden, and nothing gets added later.'</a:t>
+              <a:t>13:15–14:00 — PRICES. Say it plainly, all of it, and pause: 'Here is everything, on one slide. The consultation and your results are free. We have ONE package — the Plan Package, three ninety-nine, half and half. Everything else is separate help, only if you need it: filing help fifty with four hours of guidance included, credit analysis one fifty. Nothing is hidden, and nothing gets added later.'</a:t>
             </a:r>
           </a:p>
         </p:txBody>
@@ -1077,7 +1077,7 @@
           <a:lstStyle/>
           <a:p>
             <a:r>
-              <a:t>0:45–2:00 — YOUR STORY. Say: 'I have worked with the special needs community for five years, and I have been a life insurance agent for four. But the real reason I do this is personal. When I was eleven, I was diagnosed with juvenile rheumatoid arthritis. I watched my parents struggle — with Social Security, with medication costs, with finding help. Nobody should have to figure that out alone, at the hardest time of their life. So I built Southern Oak to be the help my family needed back then.' Pause here. This is the heart of the whole presentation. If a family member is with them, include them: 'Everything I help with touches the whole family — the benefits, the budget, the protection — so I am glad you are both here.' If the consultation is for their child, say the child's name here. Using their child's name early builds trust for everything after.</a:t>
+              <a:t>0:45–2:00 — YOUR STORY. Say: 'I have worked with the special needs community for five years, and I have been a life insurance agent for four. But the real reason I do this is personal. When I was eleven, I was diagnosed with juvenile rheumatoid arthritis. I watched my parents struggle — with Social Security, with medication costs, with finding help. Nobody should have to figure that out alone, at the hardest time of their life. So I built Southern Oak to be the help my family needed back then.' Pause here. This is the heart of the whole presentation.</a:t>
             </a:r>
           </a:p>
         </p:txBody>
@@ -1287,7 +1287,7 @@
           <a:lstStyle/>
           <a:p>
             <a:r>
-              <a:t>4:15–5:30 — THE REVIEW. Say: 'When I review your family, I look at six things.' Name each one and give a tiny example: a denial letter with a deadline nobody saw; a medicine that costs ninety dollars that could cost nine; a parent with no coverage at all; a young adult three months from eighteen with no papers started. Examples make families see their own life in the list. One more thing to name out loud: the road to eighteen. Say: 'And if your child is anywhere near eighteen, tell me today — that birthday changes how Social Security decides, and the papers for it take time, not days.' Many parents do not know the rules change at eighteen. The moment they learn it from you, you become the person they call first.</a:t>
+              <a:t>4:15–5:30 — THE REVIEW. Say: 'When I review your family, I look at six things.' Name each one and give a tiny example: a denial letter with a deadline nobody saw; a medicine that costs ninety dollars that could cost nine; a parent with no coverage at all; a young adult three months from eighteen with no papers started. Examples make families see their own life in the list.</a:t>
             </a:r>
           </a:p>
         </p:txBody>
@@ -1427,7 +1427,7 @@
           <a:lstStyle/>
           <a:p>
             <a:r>
-              <a:t>6:15–8:15 — THE PACKAGE. This is the center of the presentation — slow down. Say: 'We have ONE package. Just one. I do not believe in levels and tiers for families. The Plan Package is three hundred ninety-nine dollars, one time. I build your whole plan in writing — what to do first, second, third — with every deadline on it. You pay half when you sign, and the second half only before I hand you your plan. Then we go through it together on Zoom, line by line, until your questions are answered. Planning firms charge almost three thousand dollars for this. Ours is built for families like yours — and priced so you can actually have it.' While you are on this slide, be very clear about the two payments: 'The first half is due when you sign the agreement — that is when I start building. The second half is due before I provide the plan. If life happens and the second half has to wait, your plan waits with me, ready — nothing is lost, and there are no late fees or extra charges. When you are ready, we finish.' Say this slowly; it is the part families worry about most.</a:t>
+              <a:t>6:15–8:15 — THE PACKAGE. This is the center of the presentation — slow down. Say: 'We have ONE package. Just one. I do not believe in levels and tiers for families. The Plan Package is three hundred ninety-nine dollars, one time. I build your whole plan in writing — what to do first, second, third — with every deadline on it. You pay half when you sign, and the second half only before I hand you your plan. Then we go through it together on Zoom, line by line, until your questions are answered. Planning firms charge almost three thousand dollars for this. Ours is built for families like yours — and priced so you can actually have it.'</a:t>
             </a:r>
           </a:p>
         </p:txBody>
@@ -1567,7 +1567,7 @@
           <a:lstStyle/>
           <a:p>
             <a:r>
-              <a:t>9:15–10:15 — CHILD AND YOUNG ADULT BUILDS. Say: 'For a child, the plan is about being ready. Waiver lists can take years. Decision papers cannot be signed in a panic the week of a birthday. For a young adult, the plan is about real life: What comes in? What does rent, food, and rides really cost? And the filing itself — because at eighteen, Social Security looks at them as an adult, and the case is decided again under adult rules. We plan for that birthday starting at sixteen or seventeen, not after it.' Give one real-feeling example, without any real client's name: 'I worked with a young man turning eighteen whose family had never heard of the resource limit — two thousand dollars. One savings account in his name would have cost him his benefits. In his plan, we fixed that months before the birthday, calmly, instead of in a crisis.' Stories like this are what families remember after the Zoom ends.</a:t>
+              <a:t>9:15–10:15 — CHILD AND YOUNG ADULT BUILDS. Say: 'For a child, the plan is about being ready. Waiver lists can take years. Decision papers cannot be signed in a panic the week of a birthday. For a young adult, the plan is about real life: What comes in? What does rent, food, and rides really cost? And the filing itself — because at eighteen, Social Security looks at them as an adult, and the case is decided again under adult rules. We plan for that birthday starting at sixteen or seventeen, not after it.'</a:t>
             </a:r>
           </a:p>
         </p:txBody>
@@ -5727,7 +5727,7 @@
                 </a:solidFill>
                 <a:latin typeface="Georgia"/>
               </a:rPr>
-              <a:t>Guidance Zooms — Help When You Get Stuck</a:t>
+              <a:t>Help Is Included — SSA Filing Help</a:t>
             </a:r>
           </a:p>
         </p:txBody>
@@ -5766,7 +5766,7 @@
                 </a:solidFill>
                 <a:latin typeface="Georgia"/>
               </a:rPr>
-              <a:t>•  A 30-minute Zoom with Jessica, on the one thing you are stuck on</a:t>
+              <a:t>•  SSA filing help — $50, paid in full: you get the steps, and you file with Jessica guiding you</a:t>
             </a:r>
           </a:p>
           <a:p>
@@ -5782,7 +5782,7 @@
                 </a:solidFill>
                 <a:latin typeface="Georgia"/>
               </a:rPr>
-              <a:t>•  $26 per appointment — pay, then email us to set your time</a:t>
+              <a:t>•  Up to 4 hours of Zoom guidance included, until your filing is complete</a:t>
             </a:r>
           </a:p>
           <a:p>
@@ -5798,7 +5798,7 @@
                 </a:solidFill>
                 <a:latin typeface="Georgia"/>
               </a:rPr>
-              <a:t>•  Book only when you need one — you never pay for help you did not book</a:t>
+              <a:t>•  Need more time? Extra guidance is $10 per 30 minutes — only for the time you use</a:t>
             </a:r>
           </a:p>
           <a:p>
@@ -5814,7 +5814,7 @@
                 </a:solidFill>
                 <a:latin typeface="Georgia"/>
               </a:rPr>
-              <a:t>•  Perfect after your plan, or with your results page in hand</a:t>
+              <a:t>•  Questions any time — email us: southernoakfw@gmail.com</a:t>
             </a:r>
           </a:p>
         </p:txBody>
@@ -6107,7 +6107,7 @@
                 </a:solidFill>
                 <a:latin typeface="Georgia"/>
               </a:rPr>
-              <a:t>•  Guidance Zoom, 30 minutes — $26 · Medication check — FREE · Life insurance talk — FREE</a:t>
+              <a:t>•  Medication check — FREE · Life insurance talk — FREE</a:t>
             </a:r>
           </a:p>
         </p:txBody>

</xml_diff>

<commit_message>
Personal price update: plan no longer has a set $399 price
</commit_message>
<xml_diff>
--- a/assets/Southern-Oak-What-We-Do.pptx
+++ b/assets/Southern-Oak-What-We-Do.pptx
@@ -6059,7 +6059,7 @@
                 </a:solidFill>
                 <a:latin typeface="Georgia"/>
               </a:rPr>
-              <a:t>•  THE PACKAGE — our only package: The Plan Package — $399, pay 50/50</a:t>
+              <a:t>•  THE PACKAGE — our only package: Your Personal Plan — priced for your family, pay 50/50</a:t>
             </a:r>
           </a:p>
           <a:p>
@@ -8393,7 +8393,7 @@
                 </a:solidFill>
                 <a:latin typeface="Georgia"/>
               </a:rPr>
-              <a:t>Our Only Package — The Plan Package</a:t>
+              <a:t>Our Only Package — Your Personal Plan</a:t>
             </a:r>
           </a:p>
         </p:txBody>
@@ -8496,7 +8496,7 @@
                 </a:solidFill>
                 <a:latin typeface="Georgia"/>
               </a:rPr>
-              <a:t>•  $399 one time — pay 50/50: $199.50 when you sign, $199.50 before we provide your plan</a:t>
+              <a:t>•  Priced for your family — pay 50/50: half when you sign, half before we provide your plan</a:t>
             </a:r>
           </a:p>
         </p:txBody>

</xml_diff>